<commit_message>
Embed rendered UI mockups into production deck; add mockup render script
</commit_message>
<xml_diff>
--- a/docs/tanachok-production-slides.pptx
+++ b/docs/tanachok-production-slides.pptx
@@ -17,6 +17,9 @@
     <p:sldId id="265" r:id="rId16"/>
     <p:sldId id="266" r:id="rId17"/>
     <p:sldId id="267" r:id="rId18"/>
+    <p:sldId id="268" r:id="rId19"/>
+    <p:sldId id="269" r:id="rId20"/>
+    <p:sldId id="270" r:id="rId21"/>
   </p:sldIdLst>
   <p:sldSz cx="12191695" cy="6858000" type="screen4x3"/>
   <p:notesSz cx="6858000" cy="9144000"/>
@@ -3544,7 +3547,7 @@
                 <a:cs typeface="Tahoma"/>
                 <a:ea typeface="Tahoma"/>
               </a:rPr>
-              <a:t>ตัวอย่างให้เห็นภาพ</a:t>
+              <a:t>ตัวอย่างหน้าจอที่เสนอ</a:t>
             </a:r>
           </a:p>
         </p:txBody>
@@ -3591,7 +3594,7 @@
                 <a:cs typeface="Tahoma"/>
                 <a:ea typeface="Tahoma"/>
               </a:rPr>
-              <a:t>ตัวอย่างหน้าจอที่เสนอ</a:t>
+              <a:t>หน้าจอ 1 · ภาพรวมระบบ</a:t>
             </a:r>
           </a:p>
         </p:txBody>
@@ -3604,8 +3607,8 @@
         </p:nvSpPr>
         <p:spPr>
           <a:xfrm>
-            <a:off x="548640" y="1280160"/>
-            <a:ext cx="11064240" cy="640080"/>
+            <a:off x="548640" y="1207008"/>
+            <a:ext cx="11091672" cy="329184"/>
           </a:xfrm>
           <a:prstGeom prst="rect">
             <a:avLst/>
@@ -3630,7 +3633,7 @@
               </a:spcAft>
             </a:pPr>
             <a:r>
-              <a:rPr sz="1400" b="0">
+              <a:rPr sz="1250" b="0">
                 <a:solidFill>
                   <a:srgbClr val="5A6672"/>
                 </a:solidFill>
@@ -3638,111 +3641,45 @@
                 <a:cs typeface="Tahoma"/>
                 <a:ea typeface="Tahoma"/>
               </a:rPr>
-              <a:t>ภาพร่างหน้าจอเพื่อใช้หารือ — ยังไม่ใช่ข้อสรุป ปรับได้ตามความเห็นของเจ้าของระบบ</a:t>
-            </a:r>
-          </a:p>
-        </p:txBody>
-      </p:sp>
-      <p:sp>
-        <p:nvSpPr>
-          <p:cNvPr id="8" name="Rounded Rectangle 7"/>
-          <p:cNvSpPr/>
-          <p:nvPr/>
-        </p:nvSpPr>
-        <p:spPr>
-          <a:xfrm>
-            <a:off x="548640" y="2148840"/>
-            <a:ext cx="3587496" cy="1371600"/>
-          </a:xfrm>
-          <a:prstGeom prst="roundRect">
-            <a:avLst/>
-          </a:prstGeom>
-          <a:solidFill>
-            <a:srgbClr val="F4F1F6"/>
-          </a:solidFill>
-          <a:ln w="12700">
-            <a:solidFill>
-              <a:srgbClr val="D9CED6"/>
-            </a:solidFill>
-          </a:ln>
-          <a:effectLst/>
-        </p:spPr>
-        <p:style>
-          <a:lnRef idx="1">
-            <a:schemeClr val="accent1"/>
-          </a:lnRef>
-          <a:fillRef idx="3">
-            <a:schemeClr val="accent1"/>
-          </a:fillRef>
-          <a:effectRef idx="2">
-            <a:schemeClr val="accent1"/>
-          </a:effectRef>
-          <a:fontRef idx="minor">
-            <a:schemeClr val="lt1"/>
-          </a:fontRef>
-        </p:style>
-        <p:txBody>
-          <a:bodyPr rtlCol="0" anchor="ctr"/>
-          <a:lstStyle/>
-          <a:p>
-            <a:pPr algn="ctr"/>
-          </a:p>
-        </p:txBody>
-      </p:sp>
-      <p:sp>
-        <p:nvSpPr>
-          <p:cNvPr id="9" name="Rectangle 8"/>
-          <p:cNvSpPr/>
-          <p:nvPr/>
-        </p:nvSpPr>
-        <p:spPr>
-          <a:xfrm>
-            <a:off x="548640" y="2148840"/>
-            <a:ext cx="118872" cy="1371600"/>
-          </a:xfrm>
-          <a:prstGeom prst="rect">
-            <a:avLst/>
-          </a:prstGeom>
-          <a:solidFill>
-            <a:srgbClr val="EC008C"/>
-          </a:solidFill>
-          <a:ln>
-            <a:noFill/>
-          </a:ln>
-          <a:effectLst/>
-        </p:spPr>
-        <p:style>
-          <a:lnRef idx="1">
-            <a:schemeClr val="accent1"/>
-          </a:lnRef>
-          <a:fillRef idx="3">
-            <a:schemeClr val="accent1"/>
-          </a:fillRef>
-          <a:effectRef idx="2">
-            <a:schemeClr val="accent1"/>
-          </a:effectRef>
-          <a:fontRef idx="minor">
-            <a:schemeClr val="lt1"/>
-          </a:fontRef>
-        </p:style>
-        <p:txBody>
-          <a:bodyPr rtlCol="0" anchor="ctr"/>
-          <a:lstStyle/>
-          <a:p>
-            <a:pPr algn="ctr"/>
-          </a:p>
-        </p:txBody>
-      </p:sp>
-      <p:sp>
-        <p:nvSpPr>
-          <p:cNvPr id="10" name="TextBox 9"/>
+              <a:t>ผู้ดูแลเห็นตัวเลขสำคัญ สถานะงานส่งข้อมูล และรายการล่าสุดในหน้าเดียว</a:t>
+            </a:r>
+          </a:p>
+        </p:txBody>
+      </p:sp>
+      <p:pic>
+        <p:nvPicPr>
+          <p:cNvPr id="8" name="Picture 7" descr="screen1-dashboard.png"/>
+          <p:cNvPicPr>
+            <a:picLocks noChangeAspect="1"/>
+          </p:cNvPicPr>
+          <p:nvPr/>
+        </p:nvPicPr>
+        <p:blipFill>
+          <a:blip r:embed="rId2"/>
+          <a:stretch>
+            <a:fillRect/>
+          </a:stretch>
+        </p:blipFill>
+        <p:spPr>
+          <a:xfrm>
+            <a:off x="548640" y="1627632"/>
+            <a:ext cx="11091672" cy="6932295"/>
+          </a:xfrm>
+          <a:prstGeom prst="rect">
+            <a:avLst/>
+          </a:prstGeom>
+        </p:spPr>
+      </p:pic>
+      <p:sp>
+        <p:nvSpPr>
+          <p:cNvPr id="9" name="TextBox 8"/>
           <p:cNvSpPr txBox="1"/>
           <p:nvPr/>
         </p:nvSpPr>
         <p:spPr>
           <a:xfrm>
-            <a:off x="804672" y="2295144"/>
-            <a:ext cx="3221736" cy="365760"/>
+            <a:off x="548640" y="6355080"/>
+            <a:ext cx="11091672" cy="274320"/>
           </a:xfrm>
           <a:prstGeom prst="rect">
             <a:avLst/>
@@ -3767,29 +3704,29 @@
               </a:spcAft>
             </a:pPr>
             <a:r>
-              <a:rPr sz="1600" b="1">
-                <a:solidFill>
-                  <a:srgbClr val="222B36"/>
-                </a:solidFill>
-                <a:latin typeface="Tahoma"/>
-                <a:cs typeface="Tahoma"/>
-                <a:ea typeface="Tahoma"/>
-              </a:rPr>
-              <a:t>หน้าภาพรวม</a:t>
-            </a:r>
-          </a:p>
-        </p:txBody>
-      </p:sp>
-      <p:sp>
-        <p:nvSpPr>
-          <p:cNvPr id="11" name="TextBox 10"/>
+              <a:rPr sz="1000" b="0">
+                <a:solidFill>
+                  <a:srgbClr val="5A6672"/>
+                </a:solidFill>
+                <a:latin typeface="Tahoma"/>
+                <a:cs typeface="Tahoma"/>
+                <a:ea typeface="Tahoma"/>
+              </a:rPr>
+              <a:t>ภาพร่างเพื่อใช้หารือ · ข้อมูลบนหน้าจอเป็นตัวอย่างสมมติ ไม่ใช่ข้อมูลจริงของลูกค้า</a:t>
+            </a:r>
+          </a:p>
+        </p:txBody>
+      </p:sp>
+      <p:sp>
+        <p:nvSpPr>
+          <p:cNvPr id="10" name="TextBox 9"/>
           <p:cNvSpPr txBox="1"/>
           <p:nvPr/>
         </p:nvSpPr>
         <p:spPr>
           <a:xfrm>
-            <a:off x="804672" y="2715768"/>
-            <a:ext cx="3221736" cy="320040"/>
+            <a:off x="548640" y="6473952"/>
+            <a:ext cx="8229600" cy="274320"/>
           </a:xfrm>
           <a:prstGeom prst="rect">
             <a:avLst/>
@@ -3814,54 +3751,7 @@
               </a:spcAft>
             </a:pPr>
             <a:r>
-              <a:rPr sz="1250" b="1">
-                <a:solidFill>
-                  <a:srgbClr val="B3006A"/>
-                </a:solidFill>
-                <a:latin typeface="Tahoma"/>
-                <a:cs typeface="Tahoma"/>
-                <a:ea typeface="Tahoma"/>
-              </a:rPr>
-              <a:t>Dashboard</a:t>
-            </a:r>
-          </a:p>
-        </p:txBody>
-      </p:sp>
-      <p:sp>
-        <p:nvSpPr>
-          <p:cNvPr id="12" name="TextBox 11"/>
-          <p:cNvSpPr txBox="1"/>
-          <p:nvPr/>
-        </p:nvSpPr>
-        <p:spPr>
-          <a:xfrm>
-            <a:off x="804672" y="3063240"/>
-            <a:ext cx="3221736" cy="365760"/>
-          </a:xfrm>
-          <a:prstGeom prst="rect">
-            <a:avLst/>
-          </a:prstGeom>
-          <a:noFill/>
-        </p:spPr>
-        <p:txBody>
-          <a:bodyPr wrap="square" anchor="t">
-            <a:spAutoFit/>
-          </a:bodyPr>
-          <a:lstStyle/>
-          <a:p>
-            <a:pPr algn="l">
-              <a:lnSpc>
-                <a:spcPct val="105000"/>
-              </a:lnSpc>
-              <a:spcBef>
-                <a:spcPts val="0"/>
-              </a:spcBef>
-              <a:spcAft>
-                <a:spcPts val="400"/>
-              </a:spcAft>
-            </a:pPr>
-            <a:r>
-              <a:rPr sz="1200" b="0">
+              <a:rPr sz="900" b="0">
                 <a:solidFill>
                   <a:srgbClr val="5A6672"/>
                 </a:solidFill>
@@ -3869,1208 +3759,6 @@
                 <a:cs typeface="Tahoma"/>
                 <a:ea typeface="Tahoma"/>
               </a:rPr>
-              <a:t>สรุปยอดสลาก ธุรกรรมวันนี้ สถานะงาน Feed</a:t>
-            </a:r>
-          </a:p>
-        </p:txBody>
-      </p:sp>
-      <p:sp>
-        <p:nvSpPr>
-          <p:cNvPr id="13" name="Rounded Rectangle 12"/>
-          <p:cNvSpPr/>
-          <p:nvPr/>
-        </p:nvSpPr>
-        <p:spPr>
-          <a:xfrm>
-            <a:off x="4300728" y="2148840"/>
-            <a:ext cx="3587496" cy="1371600"/>
-          </a:xfrm>
-          <a:prstGeom prst="roundRect">
-            <a:avLst/>
-          </a:prstGeom>
-          <a:solidFill>
-            <a:srgbClr val="F4F1F6"/>
-          </a:solidFill>
-          <a:ln w="12700">
-            <a:solidFill>
-              <a:srgbClr val="D9CED6"/>
-            </a:solidFill>
-          </a:ln>
-          <a:effectLst/>
-        </p:spPr>
-        <p:style>
-          <a:lnRef idx="1">
-            <a:schemeClr val="accent1"/>
-          </a:lnRef>
-          <a:fillRef idx="3">
-            <a:schemeClr val="accent1"/>
-          </a:fillRef>
-          <a:effectRef idx="2">
-            <a:schemeClr val="accent1"/>
-          </a:effectRef>
-          <a:fontRef idx="minor">
-            <a:schemeClr val="lt1"/>
-          </a:fontRef>
-        </p:style>
-        <p:txBody>
-          <a:bodyPr rtlCol="0" anchor="ctr"/>
-          <a:lstStyle/>
-          <a:p>
-            <a:pPr algn="ctr"/>
-          </a:p>
-        </p:txBody>
-      </p:sp>
-      <p:sp>
-        <p:nvSpPr>
-          <p:cNvPr id="14" name="Rectangle 13"/>
-          <p:cNvSpPr/>
-          <p:nvPr/>
-        </p:nvSpPr>
-        <p:spPr>
-          <a:xfrm>
-            <a:off x="4300728" y="2148840"/>
-            <a:ext cx="118872" cy="1371600"/>
-          </a:xfrm>
-          <a:prstGeom prst="rect">
-            <a:avLst/>
-          </a:prstGeom>
-          <a:solidFill>
-            <a:srgbClr val="234D80"/>
-          </a:solidFill>
-          <a:ln>
-            <a:noFill/>
-          </a:ln>
-          <a:effectLst/>
-        </p:spPr>
-        <p:style>
-          <a:lnRef idx="1">
-            <a:schemeClr val="accent1"/>
-          </a:lnRef>
-          <a:fillRef idx="3">
-            <a:schemeClr val="accent1"/>
-          </a:fillRef>
-          <a:effectRef idx="2">
-            <a:schemeClr val="accent1"/>
-          </a:effectRef>
-          <a:fontRef idx="minor">
-            <a:schemeClr val="lt1"/>
-          </a:fontRef>
-        </p:style>
-        <p:txBody>
-          <a:bodyPr rtlCol="0" anchor="ctr"/>
-          <a:lstStyle/>
-          <a:p>
-            <a:pPr algn="ctr"/>
-          </a:p>
-        </p:txBody>
-      </p:sp>
-      <p:sp>
-        <p:nvSpPr>
-          <p:cNvPr id="15" name="TextBox 14"/>
-          <p:cNvSpPr txBox="1"/>
-          <p:nvPr/>
-        </p:nvSpPr>
-        <p:spPr>
-          <a:xfrm>
-            <a:off x="4556760" y="2295144"/>
-            <a:ext cx="3221736" cy="365760"/>
-          </a:xfrm>
-          <a:prstGeom prst="rect">
-            <a:avLst/>
-          </a:prstGeom>
-          <a:noFill/>
-        </p:spPr>
-        <p:txBody>
-          <a:bodyPr wrap="square" anchor="t">
-            <a:spAutoFit/>
-          </a:bodyPr>
-          <a:lstStyle/>
-          <a:p>
-            <a:pPr algn="l">
-              <a:lnSpc>
-                <a:spcPct val="100000"/>
-              </a:lnSpc>
-              <a:spcBef>
-                <a:spcPts val="0"/>
-              </a:spcBef>
-              <a:spcAft>
-                <a:spcPts val="400"/>
-              </a:spcAft>
-            </a:pPr>
-            <a:r>
-              <a:rPr sz="1600" b="1">
-                <a:solidFill>
-                  <a:srgbClr val="222B36"/>
-                </a:solidFill>
-                <a:latin typeface="Tahoma"/>
-                <a:cs typeface="Tahoma"/>
-                <a:ea typeface="Tahoma"/>
-              </a:rPr>
-              <a:t>ค้นหาผู้ถือสลาก</a:t>
-            </a:r>
-          </a:p>
-        </p:txBody>
-      </p:sp>
-      <p:sp>
-        <p:nvSpPr>
-          <p:cNvPr id="16" name="TextBox 15"/>
-          <p:cNvSpPr txBox="1"/>
-          <p:nvPr/>
-        </p:nvSpPr>
-        <p:spPr>
-          <a:xfrm>
-            <a:off x="4556760" y="2715768"/>
-            <a:ext cx="3221736" cy="320040"/>
-          </a:xfrm>
-          <a:prstGeom prst="rect">
-            <a:avLst/>
-          </a:prstGeom>
-          <a:noFill/>
-        </p:spPr>
-        <p:txBody>
-          <a:bodyPr wrap="square" anchor="t">
-            <a:spAutoFit/>
-          </a:bodyPr>
-          <a:lstStyle/>
-          <a:p>
-            <a:pPr algn="l">
-              <a:lnSpc>
-                <a:spcPct val="100000"/>
-              </a:lnSpc>
-              <a:spcBef>
-                <a:spcPts val="0"/>
-              </a:spcBef>
-              <a:spcAft>
-                <a:spcPts val="400"/>
-              </a:spcAft>
-            </a:pPr>
-            <a:r>
-              <a:rPr sz="1250" b="1">
-                <a:solidFill>
-                  <a:srgbClr val="B3006A"/>
-                </a:solidFill>
-                <a:latin typeface="Tahoma"/>
-                <a:cs typeface="Tahoma"/>
-                <a:ea typeface="Tahoma"/>
-              </a:rPr>
-              <a:t>ค้นหา/ตรวจสอบ</a:t>
-            </a:r>
-          </a:p>
-        </p:txBody>
-      </p:sp>
-      <p:sp>
-        <p:nvSpPr>
-          <p:cNvPr id="17" name="TextBox 16"/>
-          <p:cNvSpPr txBox="1"/>
-          <p:nvPr/>
-        </p:nvSpPr>
-        <p:spPr>
-          <a:xfrm>
-            <a:off x="4556760" y="3063240"/>
-            <a:ext cx="3221736" cy="365760"/>
-          </a:xfrm>
-          <a:prstGeom prst="rect">
-            <a:avLst/>
-          </a:prstGeom>
-          <a:noFill/>
-        </p:spPr>
-        <p:txBody>
-          <a:bodyPr wrap="square" anchor="t">
-            <a:spAutoFit/>
-          </a:bodyPr>
-          <a:lstStyle/>
-          <a:p>
-            <a:pPr algn="l">
-              <a:lnSpc>
-                <a:spcPct val="105000"/>
-              </a:lnSpc>
-              <a:spcBef>
-                <a:spcPts val="0"/>
-              </a:spcBef>
-              <a:spcAft>
-                <a:spcPts val="400"/>
-              </a:spcAft>
-            </a:pPr>
-            <a:r>
-              <a:rPr sz="1200" b="0">
-                <a:solidFill>
-                  <a:srgbClr val="5A6672"/>
-                </a:solidFill>
-                <a:latin typeface="Tahoma"/>
-                <a:cs typeface="Tahoma"/>
-                <a:ea typeface="Tahoma"/>
-              </a:rPr>
-              <a:t>ค้นด้วยเลขที่สลาก เลขบัตร หรือชื่อลูกค้า</a:t>
-            </a:r>
-          </a:p>
-        </p:txBody>
-      </p:sp>
-      <p:sp>
-        <p:nvSpPr>
-          <p:cNvPr id="18" name="Rounded Rectangle 17"/>
-          <p:cNvSpPr/>
-          <p:nvPr/>
-        </p:nvSpPr>
-        <p:spPr>
-          <a:xfrm>
-            <a:off x="8052816" y="2148840"/>
-            <a:ext cx="3587496" cy="1371600"/>
-          </a:xfrm>
-          <a:prstGeom prst="roundRect">
-            <a:avLst/>
-          </a:prstGeom>
-          <a:solidFill>
-            <a:srgbClr val="F4F1F6"/>
-          </a:solidFill>
-          <a:ln w="12700">
-            <a:solidFill>
-              <a:srgbClr val="D9CED6"/>
-            </a:solidFill>
-          </a:ln>
-          <a:effectLst/>
-        </p:spPr>
-        <p:style>
-          <a:lnRef idx="1">
-            <a:schemeClr val="accent1"/>
-          </a:lnRef>
-          <a:fillRef idx="3">
-            <a:schemeClr val="accent1"/>
-          </a:fillRef>
-          <a:effectRef idx="2">
-            <a:schemeClr val="accent1"/>
-          </a:effectRef>
-          <a:fontRef idx="minor">
-            <a:schemeClr val="lt1"/>
-          </a:fontRef>
-        </p:style>
-        <p:txBody>
-          <a:bodyPr rtlCol="0" anchor="ctr"/>
-          <a:lstStyle/>
-          <a:p>
-            <a:pPr algn="ctr"/>
-          </a:p>
-        </p:txBody>
-      </p:sp>
-      <p:sp>
-        <p:nvSpPr>
-          <p:cNvPr id="19" name="Rectangle 18"/>
-          <p:cNvSpPr/>
-          <p:nvPr/>
-        </p:nvSpPr>
-        <p:spPr>
-          <a:xfrm>
-            <a:off x="8052816" y="2148840"/>
-            <a:ext cx="118872" cy="1371600"/>
-          </a:xfrm>
-          <a:prstGeom prst="rect">
-            <a:avLst/>
-          </a:prstGeom>
-          <a:solidFill>
-            <a:srgbClr val="B98612"/>
-          </a:solidFill>
-          <a:ln>
-            <a:noFill/>
-          </a:ln>
-          <a:effectLst/>
-        </p:spPr>
-        <p:style>
-          <a:lnRef idx="1">
-            <a:schemeClr val="accent1"/>
-          </a:lnRef>
-          <a:fillRef idx="3">
-            <a:schemeClr val="accent1"/>
-          </a:fillRef>
-          <a:effectRef idx="2">
-            <a:schemeClr val="accent1"/>
-          </a:effectRef>
-          <a:fontRef idx="minor">
-            <a:schemeClr val="lt1"/>
-          </a:fontRef>
-        </p:style>
-        <p:txBody>
-          <a:bodyPr rtlCol="0" anchor="ctr"/>
-          <a:lstStyle/>
-          <a:p>
-            <a:pPr algn="ctr"/>
-          </a:p>
-        </p:txBody>
-      </p:sp>
-      <p:sp>
-        <p:nvSpPr>
-          <p:cNvPr id="20" name="TextBox 19"/>
-          <p:cNvSpPr txBox="1"/>
-          <p:nvPr/>
-        </p:nvSpPr>
-        <p:spPr>
-          <a:xfrm>
-            <a:off x="8308847" y="2295144"/>
-            <a:ext cx="3221736" cy="365760"/>
-          </a:xfrm>
-          <a:prstGeom prst="rect">
-            <a:avLst/>
-          </a:prstGeom>
-          <a:noFill/>
-        </p:spPr>
-        <p:txBody>
-          <a:bodyPr wrap="square" anchor="t">
-            <a:spAutoFit/>
-          </a:bodyPr>
-          <a:lstStyle/>
-          <a:p>
-            <a:pPr algn="l">
-              <a:lnSpc>
-                <a:spcPct val="100000"/>
-              </a:lnSpc>
-              <a:spcBef>
-                <a:spcPts val="0"/>
-              </a:spcBef>
-              <a:spcAft>
-                <a:spcPts val="400"/>
-              </a:spcAft>
-            </a:pPr>
-            <a:r>
-              <a:rPr sz="1600" b="1">
-                <a:solidFill>
-                  <a:srgbClr val="222B36"/>
-                </a:solidFill>
-                <a:latin typeface="Tahoma"/>
-                <a:cs typeface="Tahoma"/>
-                <a:ea typeface="Tahoma"/>
-              </a:rPr>
-              <a:t>รายละเอียดสลาก</a:t>
-            </a:r>
-          </a:p>
-        </p:txBody>
-      </p:sp>
-      <p:sp>
-        <p:nvSpPr>
-          <p:cNvPr id="21" name="TextBox 20"/>
-          <p:cNvSpPr txBox="1"/>
-          <p:nvPr/>
-        </p:nvSpPr>
-        <p:spPr>
-          <a:xfrm>
-            <a:off x="8308847" y="2715768"/>
-            <a:ext cx="3221736" cy="320040"/>
-          </a:xfrm>
-          <a:prstGeom prst="rect">
-            <a:avLst/>
-          </a:prstGeom>
-          <a:noFill/>
-        </p:spPr>
-        <p:txBody>
-          <a:bodyPr wrap="square" anchor="t">
-            <a:spAutoFit/>
-          </a:bodyPr>
-          <a:lstStyle/>
-          <a:p>
-            <a:pPr algn="l">
-              <a:lnSpc>
-                <a:spcPct val="100000"/>
-              </a:lnSpc>
-              <a:spcBef>
-                <a:spcPts val="0"/>
-              </a:spcBef>
-              <a:spcAft>
-                <a:spcPts val="400"/>
-              </a:spcAft>
-            </a:pPr>
-            <a:r>
-              <a:rPr sz="1250" b="1">
-                <a:solidFill>
-                  <a:srgbClr val="B3006A"/>
-                </a:solidFill>
-                <a:latin typeface="Tahoma"/>
-                <a:cs typeface="Tahoma"/>
-                <a:ea typeface="Tahoma"/>
-              </a:rPr>
-              <a:t>ทะเบียนสลาก</a:t>
-            </a:r>
-          </a:p>
-        </p:txBody>
-      </p:sp>
-      <p:sp>
-        <p:nvSpPr>
-          <p:cNvPr id="22" name="TextBox 21"/>
-          <p:cNvSpPr txBox="1"/>
-          <p:nvPr/>
-        </p:nvSpPr>
-        <p:spPr>
-          <a:xfrm>
-            <a:off x="8308847" y="3063240"/>
-            <a:ext cx="3221736" cy="365760"/>
-          </a:xfrm>
-          <a:prstGeom prst="rect">
-            <a:avLst/>
-          </a:prstGeom>
-          <a:noFill/>
-        </p:spPr>
-        <p:txBody>
-          <a:bodyPr wrap="square" anchor="t">
-            <a:spAutoFit/>
-          </a:bodyPr>
-          <a:lstStyle/>
-          <a:p>
-            <a:pPr algn="l">
-              <a:lnSpc>
-                <a:spcPct val="105000"/>
-              </a:lnSpc>
-              <a:spcBef>
-                <a:spcPts val="0"/>
-              </a:spcBef>
-              <a:spcAft>
-                <a:spcPts val="400"/>
-              </a:spcAft>
-            </a:pPr>
-            <a:r>
-              <a:rPr sz="1200" b="0">
-                <a:solidFill>
-                  <a:srgbClr val="5A6672"/>
-                </a:solidFill>
-                <a:latin typeface="Tahoma"/>
-                <a:cs typeface="Tahoma"/>
-                <a:ea typeface="Tahoma"/>
-              </a:rPr>
-              <a:t>ข้อมูลสลาก ประวัติธุรกรรม และผลการตรวจรางวัล</a:t>
-            </a:r>
-          </a:p>
-        </p:txBody>
-      </p:sp>
-      <p:sp>
-        <p:nvSpPr>
-          <p:cNvPr id="23" name="Rounded Rectangle 22"/>
-          <p:cNvSpPr/>
-          <p:nvPr/>
-        </p:nvSpPr>
-        <p:spPr>
-          <a:xfrm>
-            <a:off x="548640" y="3703320"/>
-            <a:ext cx="3587496" cy="1371600"/>
-          </a:xfrm>
-          <a:prstGeom prst="roundRect">
-            <a:avLst/>
-          </a:prstGeom>
-          <a:solidFill>
-            <a:srgbClr val="F4F1F6"/>
-          </a:solidFill>
-          <a:ln w="12700">
-            <a:solidFill>
-              <a:srgbClr val="D9CED6"/>
-            </a:solidFill>
-          </a:ln>
-          <a:effectLst/>
-        </p:spPr>
-        <p:style>
-          <a:lnRef idx="1">
-            <a:schemeClr val="accent1"/>
-          </a:lnRef>
-          <a:fillRef idx="3">
-            <a:schemeClr val="accent1"/>
-          </a:fillRef>
-          <a:effectRef idx="2">
-            <a:schemeClr val="accent1"/>
-          </a:effectRef>
-          <a:fontRef idx="minor">
-            <a:schemeClr val="lt1"/>
-          </a:fontRef>
-        </p:style>
-        <p:txBody>
-          <a:bodyPr rtlCol="0" anchor="ctr"/>
-          <a:lstStyle/>
-          <a:p>
-            <a:pPr algn="ctr"/>
-          </a:p>
-        </p:txBody>
-      </p:sp>
-      <p:sp>
-        <p:nvSpPr>
-          <p:cNvPr id="24" name="Rectangle 23"/>
-          <p:cNvSpPr/>
-          <p:nvPr/>
-        </p:nvSpPr>
-        <p:spPr>
-          <a:xfrm>
-            <a:off x="548640" y="3703320"/>
-            <a:ext cx="118872" cy="1371600"/>
-          </a:xfrm>
-          <a:prstGeom prst="rect">
-            <a:avLst/>
-          </a:prstGeom>
-          <a:solidFill>
-            <a:srgbClr val="2E7D46"/>
-          </a:solidFill>
-          <a:ln>
-            <a:noFill/>
-          </a:ln>
-          <a:effectLst/>
-        </p:spPr>
-        <p:style>
-          <a:lnRef idx="1">
-            <a:schemeClr val="accent1"/>
-          </a:lnRef>
-          <a:fillRef idx="3">
-            <a:schemeClr val="accent1"/>
-          </a:fillRef>
-          <a:effectRef idx="2">
-            <a:schemeClr val="accent1"/>
-          </a:effectRef>
-          <a:fontRef idx="minor">
-            <a:schemeClr val="lt1"/>
-          </a:fontRef>
-        </p:style>
-        <p:txBody>
-          <a:bodyPr rtlCol="0" anchor="ctr"/>
-          <a:lstStyle/>
-          <a:p>
-            <a:pPr algn="ctr"/>
-          </a:p>
-        </p:txBody>
-      </p:sp>
-      <p:sp>
-        <p:nvSpPr>
-          <p:cNvPr id="25" name="TextBox 24"/>
-          <p:cNvSpPr txBox="1"/>
-          <p:nvPr/>
-        </p:nvSpPr>
-        <p:spPr>
-          <a:xfrm>
-            <a:off x="804672" y="3849624"/>
-            <a:ext cx="3221736" cy="365760"/>
-          </a:xfrm>
-          <a:prstGeom prst="rect">
-            <a:avLst/>
-          </a:prstGeom>
-          <a:noFill/>
-        </p:spPr>
-        <p:txBody>
-          <a:bodyPr wrap="square" anchor="t">
-            <a:spAutoFit/>
-          </a:bodyPr>
-          <a:lstStyle/>
-          <a:p>
-            <a:pPr algn="l">
-              <a:lnSpc>
-                <a:spcPct val="100000"/>
-              </a:lnSpc>
-              <a:spcBef>
-                <a:spcPts val="0"/>
-              </a:spcBef>
-              <a:spcAft>
-                <a:spcPts val="400"/>
-              </a:spcAft>
-            </a:pPr>
-            <a:r>
-              <a:rPr sz="1600" b="1">
-                <a:solidFill>
-                  <a:srgbClr val="222B36"/>
-                </a:solidFill>
-                <a:latin typeface="Tahoma"/>
-                <a:cs typeface="Tahoma"/>
-                <a:ea typeface="Tahoma"/>
-              </a:rPr>
-              <a:t>ตรวจและจ่ายรางวัล</a:t>
-            </a:r>
-          </a:p>
-        </p:txBody>
-      </p:sp>
-      <p:sp>
-        <p:nvSpPr>
-          <p:cNvPr id="26" name="TextBox 25"/>
-          <p:cNvSpPr txBox="1"/>
-          <p:nvPr/>
-        </p:nvSpPr>
-        <p:spPr>
-          <a:xfrm>
-            <a:off x="804672" y="4270248"/>
-            <a:ext cx="3221736" cy="320040"/>
-          </a:xfrm>
-          <a:prstGeom prst="rect">
-            <a:avLst/>
-          </a:prstGeom>
-          <a:noFill/>
-        </p:spPr>
-        <p:txBody>
-          <a:bodyPr wrap="square" anchor="t">
-            <a:spAutoFit/>
-          </a:bodyPr>
-          <a:lstStyle/>
-          <a:p>
-            <a:pPr algn="l">
-              <a:lnSpc>
-                <a:spcPct val="100000"/>
-              </a:lnSpc>
-              <a:spcBef>
-                <a:spcPts val="0"/>
-              </a:spcBef>
-              <a:spcAft>
-                <a:spcPts val="400"/>
-              </a:spcAft>
-            </a:pPr>
-            <a:r>
-              <a:rPr sz="1250" b="1">
-                <a:solidFill>
-                  <a:srgbClr val="B3006A"/>
-                </a:solidFill>
-                <a:latin typeface="Tahoma"/>
-                <a:cs typeface="Tahoma"/>
-                <a:ea typeface="Tahoma"/>
-              </a:rPr>
-              <a:t>งวดรางวัล</a:t>
-            </a:r>
-          </a:p>
-        </p:txBody>
-      </p:sp>
-      <p:sp>
-        <p:nvSpPr>
-          <p:cNvPr id="27" name="TextBox 26"/>
-          <p:cNvSpPr txBox="1"/>
-          <p:nvPr/>
-        </p:nvSpPr>
-        <p:spPr>
-          <a:xfrm>
-            <a:off x="804672" y="4617720"/>
-            <a:ext cx="3221736" cy="365760"/>
-          </a:xfrm>
-          <a:prstGeom prst="rect">
-            <a:avLst/>
-          </a:prstGeom>
-          <a:noFill/>
-        </p:spPr>
-        <p:txBody>
-          <a:bodyPr wrap="square" anchor="t">
-            <a:spAutoFit/>
-          </a:bodyPr>
-          <a:lstStyle/>
-          <a:p>
-            <a:pPr algn="l">
-              <a:lnSpc>
-                <a:spcPct val="105000"/>
-              </a:lnSpc>
-              <a:spcBef>
-                <a:spcPts val="0"/>
-              </a:spcBef>
-              <a:spcAft>
-                <a:spcPts val="400"/>
-              </a:spcAft>
-            </a:pPr>
-            <a:r>
-              <a:rPr sz="1200" b="0">
-                <a:solidFill>
-                  <a:srgbClr val="5A6672"/>
-                </a:solidFill>
-                <a:latin typeface="Tahoma"/>
-                <a:cs typeface="Tahoma"/>
-                <a:ea typeface="Tahoma"/>
-              </a:rPr>
-              <a:t>ตรวจรางวัลตามงวด และบันทึกการจ่าย</a:t>
-            </a:r>
-          </a:p>
-        </p:txBody>
-      </p:sp>
-      <p:sp>
-        <p:nvSpPr>
-          <p:cNvPr id="28" name="Rounded Rectangle 27"/>
-          <p:cNvSpPr/>
-          <p:nvPr/>
-        </p:nvSpPr>
-        <p:spPr>
-          <a:xfrm>
-            <a:off x="4300728" y="3703320"/>
-            <a:ext cx="3587496" cy="1371600"/>
-          </a:xfrm>
-          <a:prstGeom prst="roundRect">
-            <a:avLst/>
-          </a:prstGeom>
-          <a:solidFill>
-            <a:srgbClr val="F4F1F6"/>
-          </a:solidFill>
-          <a:ln w="12700">
-            <a:solidFill>
-              <a:srgbClr val="D9CED6"/>
-            </a:solidFill>
-          </a:ln>
-          <a:effectLst/>
-        </p:spPr>
-        <p:style>
-          <a:lnRef idx="1">
-            <a:schemeClr val="accent1"/>
-          </a:lnRef>
-          <a:fillRef idx="3">
-            <a:schemeClr val="accent1"/>
-          </a:fillRef>
-          <a:effectRef idx="2">
-            <a:schemeClr val="accent1"/>
-          </a:effectRef>
-          <a:fontRef idx="minor">
-            <a:schemeClr val="lt1"/>
-          </a:fontRef>
-        </p:style>
-        <p:txBody>
-          <a:bodyPr rtlCol="0" anchor="ctr"/>
-          <a:lstStyle/>
-          <a:p>
-            <a:pPr algn="ctr"/>
-          </a:p>
-        </p:txBody>
-      </p:sp>
-      <p:sp>
-        <p:nvSpPr>
-          <p:cNvPr id="29" name="Rectangle 28"/>
-          <p:cNvSpPr/>
-          <p:nvPr/>
-        </p:nvSpPr>
-        <p:spPr>
-          <a:xfrm>
-            <a:off x="4300728" y="3703320"/>
-            <a:ext cx="118872" cy="1371600"/>
-          </a:xfrm>
-          <a:prstGeom prst="rect">
-            <a:avLst/>
-          </a:prstGeom>
-          <a:solidFill>
-            <a:srgbClr val="EC008C"/>
-          </a:solidFill>
-          <a:ln>
-            <a:noFill/>
-          </a:ln>
-          <a:effectLst/>
-        </p:spPr>
-        <p:style>
-          <a:lnRef idx="1">
-            <a:schemeClr val="accent1"/>
-          </a:lnRef>
-          <a:fillRef idx="3">
-            <a:schemeClr val="accent1"/>
-          </a:fillRef>
-          <a:effectRef idx="2">
-            <a:schemeClr val="accent1"/>
-          </a:effectRef>
-          <a:fontRef idx="minor">
-            <a:schemeClr val="lt1"/>
-          </a:fontRef>
-        </p:style>
-        <p:txBody>
-          <a:bodyPr rtlCol="0" anchor="ctr"/>
-          <a:lstStyle/>
-          <a:p>
-            <a:pPr algn="ctr"/>
-          </a:p>
-        </p:txBody>
-      </p:sp>
-      <p:sp>
-        <p:nvSpPr>
-          <p:cNvPr id="30" name="TextBox 29"/>
-          <p:cNvSpPr txBox="1"/>
-          <p:nvPr/>
-        </p:nvSpPr>
-        <p:spPr>
-          <a:xfrm>
-            <a:off x="4556760" y="3849624"/>
-            <a:ext cx="3221736" cy="365760"/>
-          </a:xfrm>
-          <a:prstGeom prst="rect">
-            <a:avLst/>
-          </a:prstGeom>
-          <a:noFill/>
-        </p:spPr>
-        <p:txBody>
-          <a:bodyPr wrap="square" anchor="t">
-            <a:spAutoFit/>
-          </a:bodyPr>
-          <a:lstStyle/>
-          <a:p>
-            <a:pPr algn="l">
-              <a:lnSpc>
-                <a:spcPct val="100000"/>
-              </a:lnSpc>
-              <a:spcBef>
-                <a:spcPts val="0"/>
-              </a:spcBef>
-              <a:spcAft>
-                <a:spcPts val="400"/>
-              </a:spcAft>
-            </a:pPr>
-            <a:r>
-              <a:rPr sz="1600" b="1">
-                <a:solidFill>
-                  <a:srgbClr val="222B36"/>
-                </a:solidFill>
-                <a:latin typeface="Tahoma"/>
-                <a:cs typeface="Tahoma"/>
-                <a:ea typeface="Tahoma"/>
-              </a:rPr>
-              <a:t>งานปิด/ย้ายสาขา</a:t>
-            </a:r>
-          </a:p>
-        </p:txBody>
-      </p:sp>
-      <p:sp>
-        <p:nvSpPr>
-          <p:cNvPr id="31" name="TextBox 30"/>
-          <p:cNvSpPr txBox="1"/>
-          <p:nvPr/>
-        </p:nvSpPr>
-        <p:spPr>
-          <a:xfrm>
-            <a:off x="4556760" y="4270248"/>
-            <a:ext cx="3221736" cy="320040"/>
-          </a:xfrm>
-          <a:prstGeom prst="rect">
-            <a:avLst/>
-          </a:prstGeom>
-          <a:noFill/>
-        </p:spPr>
-        <p:txBody>
-          <a:bodyPr wrap="square" anchor="t">
-            <a:spAutoFit/>
-          </a:bodyPr>
-          <a:lstStyle/>
-          <a:p>
-            <a:pPr algn="l">
-              <a:lnSpc>
-                <a:spcPct val="100000"/>
-              </a:lnSpc>
-              <a:spcBef>
-                <a:spcPts val="0"/>
-              </a:spcBef>
-              <a:spcAft>
-                <a:spcPts val="400"/>
-              </a:spcAft>
-            </a:pPr>
-            <a:r>
-              <a:rPr sz="1250" b="1">
-                <a:solidFill>
-                  <a:srgbClr val="B3006A"/>
-                </a:solidFill>
-                <a:latin typeface="Tahoma"/>
-                <a:cs typeface="Tahoma"/>
-                <a:ea typeface="Tahoma"/>
-              </a:rPr>
-              <a:t>บริหารสาขา</a:t>
-            </a:r>
-          </a:p>
-        </p:txBody>
-      </p:sp>
-      <p:sp>
-        <p:nvSpPr>
-          <p:cNvPr id="32" name="TextBox 31"/>
-          <p:cNvSpPr txBox="1"/>
-          <p:nvPr/>
-        </p:nvSpPr>
-        <p:spPr>
-          <a:xfrm>
-            <a:off x="4556760" y="4617720"/>
-            <a:ext cx="3221736" cy="365760"/>
-          </a:xfrm>
-          <a:prstGeom prst="rect">
-            <a:avLst/>
-          </a:prstGeom>
-          <a:noFill/>
-        </p:spPr>
-        <p:txBody>
-          <a:bodyPr wrap="square" anchor="t">
-            <a:spAutoFit/>
-          </a:bodyPr>
-          <a:lstStyle/>
-          <a:p>
-            <a:pPr algn="l">
-              <a:lnSpc>
-                <a:spcPct val="105000"/>
-              </a:lnSpc>
-              <a:spcBef>
-                <a:spcPts val="0"/>
-              </a:spcBef>
-              <a:spcAft>
-                <a:spcPts val="400"/>
-              </a:spcAft>
-            </a:pPr>
-            <a:r>
-              <a:rPr sz="1200" b="0">
-                <a:solidFill>
-                  <a:srgbClr val="5A6672"/>
-                </a:solidFill>
-                <a:latin typeface="Tahoma"/>
-                <a:cs typeface="Tahoma"/>
-                <a:ea typeface="Tahoma"/>
-              </a:rPr>
-              <a:t>เลือกสาขาต้นทาง–ปลายทาง ตรวจสอบก่อนยืนยัน</a:t>
-            </a:r>
-          </a:p>
-        </p:txBody>
-      </p:sp>
-      <p:sp>
-        <p:nvSpPr>
-          <p:cNvPr id="33" name="Rounded Rectangle 32"/>
-          <p:cNvSpPr/>
-          <p:nvPr/>
-        </p:nvSpPr>
-        <p:spPr>
-          <a:xfrm>
-            <a:off x="8052816" y="3703320"/>
-            <a:ext cx="3587496" cy="1371600"/>
-          </a:xfrm>
-          <a:prstGeom prst="roundRect">
-            <a:avLst/>
-          </a:prstGeom>
-          <a:solidFill>
-            <a:srgbClr val="F4F1F6"/>
-          </a:solidFill>
-          <a:ln w="12700">
-            <a:solidFill>
-              <a:srgbClr val="D9CED6"/>
-            </a:solidFill>
-          </a:ln>
-          <a:effectLst/>
-        </p:spPr>
-        <p:style>
-          <a:lnRef idx="1">
-            <a:schemeClr val="accent1"/>
-          </a:lnRef>
-          <a:fillRef idx="3">
-            <a:schemeClr val="accent1"/>
-          </a:fillRef>
-          <a:effectRef idx="2">
-            <a:schemeClr val="accent1"/>
-          </a:effectRef>
-          <a:fontRef idx="minor">
-            <a:schemeClr val="lt1"/>
-          </a:fontRef>
-        </p:style>
-        <p:txBody>
-          <a:bodyPr rtlCol="0" anchor="ctr"/>
-          <a:lstStyle/>
-          <a:p>
-            <a:pPr algn="ctr"/>
-          </a:p>
-        </p:txBody>
-      </p:sp>
-      <p:sp>
-        <p:nvSpPr>
-          <p:cNvPr id="34" name="Rectangle 33"/>
-          <p:cNvSpPr/>
-          <p:nvPr/>
-        </p:nvSpPr>
-        <p:spPr>
-          <a:xfrm>
-            <a:off x="8052816" y="3703320"/>
-            <a:ext cx="118872" cy="1371600"/>
-          </a:xfrm>
-          <a:prstGeom prst="rect">
-            <a:avLst/>
-          </a:prstGeom>
-          <a:solidFill>
-            <a:srgbClr val="234D80"/>
-          </a:solidFill>
-          <a:ln>
-            <a:noFill/>
-          </a:ln>
-          <a:effectLst/>
-        </p:spPr>
-        <p:style>
-          <a:lnRef idx="1">
-            <a:schemeClr val="accent1"/>
-          </a:lnRef>
-          <a:fillRef idx="3">
-            <a:schemeClr val="accent1"/>
-          </a:fillRef>
-          <a:effectRef idx="2">
-            <a:schemeClr val="accent1"/>
-          </a:effectRef>
-          <a:fontRef idx="minor">
-            <a:schemeClr val="lt1"/>
-          </a:fontRef>
-        </p:style>
-        <p:txBody>
-          <a:bodyPr rtlCol="0" anchor="ctr"/>
-          <a:lstStyle/>
-          <a:p>
-            <a:pPr algn="ctr"/>
-          </a:p>
-        </p:txBody>
-      </p:sp>
-      <p:sp>
-        <p:nvSpPr>
-          <p:cNvPr id="35" name="TextBox 34"/>
-          <p:cNvSpPr txBox="1"/>
-          <p:nvPr/>
-        </p:nvSpPr>
-        <p:spPr>
-          <a:xfrm>
-            <a:off x="8308847" y="3849624"/>
-            <a:ext cx="3221736" cy="365760"/>
-          </a:xfrm>
-          <a:prstGeom prst="rect">
-            <a:avLst/>
-          </a:prstGeom>
-          <a:noFill/>
-        </p:spPr>
-        <p:txBody>
-          <a:bodyPr wrap="square" anchor="t">
-            <a:spAutoFit/>
-          </a:bodyPr>
-          <a:lstStyle/>
-          <a:p>
-            <a:pPr algn="l">
-              <a:lnSpc>
-                <a:spcPct val="100000"/>
-              </a:lnSpc>
-              <a:spcBef>
-                <a:spcPts val="0"/>
-              </a:spcBef>
-              <a:spcAft>
-                <a:spcPts val="400"/>
-              </a:spcAft>
-            </a:pPr>
-            <a:r>
-              <a:rPr sz="1600" b="1">
-                <a:solidFill>
-                  <a:srgbClr val="222B36"/>
-                </a:solidFill>
-                <a:latin typeface="Tahoma"/>
-                <a:cs typeface="Tahoma"/>
-                <a:ea typeface="Tahoma"/>
-              </a:rPr>
-              <a:t>ติดตามการส่งข้อมูล</a:t>
-            </a:r>
-          </a:p>
-        </p:txBody>
-      </p:sp>
-      <p:sp>
-        <p:nvSpPr>
-          <p:cNvPr id="36" name="TextBox 35"/>
-          <p:cNvSpPr txBox="1"/>
-          <p:nvPr/>
-        </p:nvSpPr>
-        <p:spPr>
-          <a:xfrm>
-            <a:off x="8308847" y="4270248"/>
-            <a:ext cx="3221736" cy="320040"/>
-          </a:xfrm>
-          <a:prstGeom prst="rect">
-            <a:avLst/>
-          </a:prstGeom>
-          <a:noFill/>
-        </p:spPr>
-        <p:txBody>
-          <a:bodyPr wrap="square" anchor="t">
-            <a:spAutoFit/>
-          </a:bodyPr>
-          <a:lstStyle/>
-          <a:p>
-            <a:pPr algn="l">
-              <a:lnSpc>
-                <a:spcPct val="100000"/>
-              </a:lnSpc>
-              <a:spcBef>
-                <a:spcPts val="0"/>
-              </a:spcBef>
-              <a:spcAft>
-                <a:spcPts val="400"/>
-              </a:spcAft>
-            </a:pPr>
-            <a:r>
-              <a:rPr sz="1250" b="1">
-                <a:solidFill>
-                  <a:srgbClr val="B3006A"/>
-                </a:solidFill>
-                <a:latin typeface="Tahoma"/>
-                <a:cs typeface="Tahoma"/>
-                <a:ea typeface="Tahoma"/>
-              </a:rPr>
-              <a:t>SFTP Feed</a:t>
-            </a:r>
-          </a:p>
-        </p:txBody>
-      </p:sp>
-      <p:sp>
-        <p:nvSpPr>
-          <p:cNvPr id="37" name="TextBox 36"/>
-          <p:cNvSpPr txBox="1"/>
-          <p:nvPr/>
-        </p:nvSpPr>
-        <p:spPr>
-          <a:xfrm>
-            <a:off x="8308847" y="4617720"/>
-            <a:ext cx="3221736" cy="365760"/>
-          </a:xfrm>
-          <a:prstGeom prst="rect">
-            <a:avLst/>
-          </a:prstGeom>
-          <a:noFill/>
-        </p:spPr>
-        <p:txBody>
-          <a:bodyPr wrap="square" anchor="t">
-            <a:spAutoFit/>
-          </a:bodyPr>
-          <a:lstStyle/>
-          <a:p>
-            <a:pPr algn="l">
-              <a:lnSpc>
-                <a:spcPct val="105000"/>
-              </a:lnSpc>
-              <a:spcBef>
-                <a:spcPts val="0"/>
-              </a:spcBef>
-              <a:spcAft>
-                <a:spcPts val="400"/>
-              </a:spcAft>
-            </a:pPr>
-            <a:r>
-              <a:rPr sz="1200" b="0">
-                <a:solidFill>
-                  <a:srgbClr val="5A6672"/>
-                </a:solidFill>
-                <a:latin typeface="Tahoma"/>
-                <a:cs typeface="Tahoma"/>
-                <a:ea typeface="Tahoma"/>
-              </a:rPr>
-              <a:t>สถานะรอบล่าสุด ผลสำเร็จ/ล้มเหลว และปุ่มส่งซ้ำ</a:t>
-            </a:r>
-          </a:p>
-        </p:txBody>
-      </p:sp>
-      <p:sp>
-        <p:nvSpPr>
-          <p:cNvPr id="38" name="TextBox 37"/>
-          <p:cNvSpPr txBox="1"/>
-          <p:nvPr/>
-        </p:nvSpPr>
-        <p:spPr>
-          <a:xfrm>
-            <a:off x="548640" y="6473952"/>
-            <a:ext cx="8229600" cy="274320"/>
-          </a:xfrm>
-          <a:prstGeom prst="rect">
-            <a:avLst/>
-          </a:prstGeom>
-          <a:noFill/>
-        </p:spPr>
-        <p:txBody>
-          <a:bodyPr wrap="square" anchor="t">
-            <a:spAutoFit/>
-          </a:bodyPr>
-          <a:lstStyle/>
-          <a:p>
-            <a:pPr algn="l">
-              <a:lnSpc>
-                <a:spcPct val="100000"/>
-              </a:lnSpc>
-              <a:spcBef>
-                <a:spcPts val="0"/>
-              </a:spcBef>
-              <a:spcAft>
-                <a:spcPts val="400"/>
-              </a:spcAft>
-            </a:pPr>
-            <a:r>
-              <a:rPr sz="900" b="0">
-                <a:solidFill>
-                  <a:srgbClr val="5A6672"/>
-                </a:solidFill>
-                <a:latin typeface="Tahoma"/>
-                <a:cs typeface="Tahoma"/>
-                <a:ea typeface="Tahoma"/>
-              </a:rPr>
               <a:t>TANACHOK — ระบบงานสลากธนโชค</a:t>
             </a:r>
           </a:p>
@@ -5078,7 +3766,7 @@
       </p:sp>
       <p:sp>
         <p:nvSpPr>
-          <p:cNvPr id="39" name="TextBox 38"/>
+          <p:cNvPr id="11" name="TextBox 10"/>
           <p:cNvSpPr txBox="1"/>
           <p:nvPr/>
         </p:nvSpPr>
@@ -5315,6 +4003,2689 @@
                 <a:cs typeface="Tahoma"/>
                 <a:ea typeface="Tahoma"/>
               </a:rPr>
+              <a:t>ตัวอย่างหน้าจอที่เสนอ</a:t>
+            </a:r>
+          </a:p>
+        </p:txBody>
+      </p:sp>
+      <p:sp>
+        <p:nvSpPr>
+          <p:cNvPr id="6" name="TextBox 5"/>
+          <p:cNvSpPr txBox="1"/>
+          <p:nvPr/>
+        </p:nvSpPr>
+        <p:spPr>
+          <a:xfrm>
+            <a:off x="548640" y="420624"/>
+            <a:ext cx="10972800" cy="548640"/>
+          </a:xfrm>
+          <a:prstGeom prst="rect">
+            <a:avLst/>
+          </a:prstGeom>
+          <a:noFill/>
+        </p:spPr>
+        <p:txBody>
+          <a:bodyPr wrap="square" anchor="t">
+            <a:spAutoFit/>
+          </a:bodyPr>
+          <a:lstStyle/>
+          <a:p>
+            <a:pPr algn="l">
+              <a:lnSpc>
+                <a:spcPct val="100000"/>
+              </a:lnSpc>
+              <a:spcBef>
+                <a:spcPts val="0"/>
+              </a:spcBef>
+              <a:spcAft>
+                <a:spcPts val="400"/>
+              </a:spcAft>
+            </a:pPr>
+            <a:r>
+              <a:rPr sz="2500" b="1">
+                <a:solidFill>
+                  <a:srgbClr val="FFFFFF"/>
+                </a:solidFill>
+                <a:latin typeface="Tahoma"/>
+                <a:cs typeface="Tahoma"/>
+                <a:ea typeface="Tahoma"/>
+              </a:rPr>
+              <a:t>หน้าจอ 2 · ค้นหาผู้ถือสลาก</a:t>
+            </a:r>
+          </a:p>
+        </p:txBody>
+      </p:sp>
+      <p:sp>
+        <p:nvSpPr>
+          <p:cNvPr id="7" name="TextBox 6"/>
+          <p:cNvSpPr txBox="1"/>
+          <p:nvPr/>
+        </p:nvSpPr>
+        <p:spPr>
+          <a:xfrm>
+            <a:off x="548640" y="1207008"/>
+            <a:ext cx="11091672" cy="329184"/>
+          </a:xfrm>
+          <a:prstGeom prst="rect">
+            <a:avLst/>
+          </a:prstGeom>
+          <a:noFill/>
+        </p:spPr>
+        <p:txBody>
+          <a:bodyPr wrap="square" anchor="t">
+            <a:spAutoFit/>
+          </a:bodyPr>
+          <a:lstStyle/>
+          <a:p>
+            <a:pPr algn="l">
+              <a:lnSpc>
+                <a:spcPct val="100000"/>
+              </a:lnSpc>
+              <a:spcBef>
+                <a:spcPts val="0"/>
+              </a:spcBef>
+              <a:spcAft>
+                <a:spcPts val="400"/>
+              </a:spcAft>
+            </a:pPr>
+            <a:r>
+              <a:rPr sz="1250" b="0">
+                <a:solidFill>
+                  <a:srgbClr val="5A6672"/>
+                </a:solidFill>
+                <a:latin typeface="Tahoma"/>
+                <a:cs typeface="Tahoma"/>
+                <a:ea typeface="Tahoma"/>
+              </a:rPr>
+              <a:t>ค้นด้วยเลขที่สลาก เลขบัตร หรือชื่อ แล้วเห็นรายละเอียดและประวัติธุรกรรมครบในหน้าเดียว</a:t>
+            </a:r>
+          </a:p>
+        </p:txBody>
+      </p:sp>
+      <p:pic>
+        <p:nvPicPr>
+          <p:cNvPr id="8" name="Picture 7" descr="screen2-search.png"/>
+          <p:cNvPicPr>
+            <a:picLocks noChangeAspect="1"/>
+          </p:cNvPicPr>
+          <p:nvPr/>
+        </p:nvPicPr>
+        <p:blipFill>
+          <a:blip r:embed="rId2"/>
+          <a:stretch>
+            <a:fillRect/>
+          </a:stretch>
+        </p:blipFill>
+        <p:spPr>
+          <a:xfrm>
+            <a:off x="548640" y="1627632"/>
+            <a:ext cx="11091672" cy="6932295"/>
+          </a:xfrm>
+          <a:prstGeom prst="rect">
+            <a:avLst/>
+          </a:prstGeom>
+        </p:spPr>
+      </p:pic>
+      <p:sp>
+        <p:nvSpPr>
+          <p:cNvPr id="9" name="TextBox 8"/>
+          <p:cNvSpPr txBox="1"/>
+          <p:nvPr/>
+        </p:nvSpPr>
+        <p:spPr>
+          <a:xfrm>
+            <a:off x="548640" y="6355080"/>
+            <a:ext cx="11091672" cy="274320"/>
+          </a:xfrm>
+          <a:prstGeom prst="rect">
+            <a:avLst/>
+          </a:prstGeom>
+          <a:noFill/>
+        </p:spPr>
+        <p:txBody>
+          <a:bodyPr wrap="square" anchor="t">
+            <a:spAutoFit/>
+          </a:bodyPr>
+          <a:lstStyle/>
+          <a:p>
+            <a:pPr algn="l">
+              <a:lnSpc>
+                <a:spcPct val="100000"/>
+              </a:lnSpc>
+              <a:spcBef>
+                <a:spcPts val="0"/>
+              </a:spcBef>
+              <a:spcAft>
+                <a:spcPts val="400"/>
+              </a:spcAft>
+            </a:pPr>
+            <a:r>
+              <a:rPr sz="1000" b="0">
+                <a:solidFill>
+                  <a:srgbClr val="5A6672"/>
+                </a:solidFill>
+                <a:latin typeface="Tahoma"/>
+                <a:cs typeface="Tahoma"/>
+                <a:ea typeface="Tahoma"/>
+              </a:rPr>
+              <a:t>ภาพร่างเพื่อใช้หารือ · ข้อมูลบนหน้าจอเป็นตัวอย่างสมมติ ไม่ใช่ข้อมูลจริงของลูกค้า</a:t>
+            </a:r>
+          </a:p>
+        </p:txBody>
+      </p:sp>
+      <p:sp>
+        <p:nvSpPr>
+          <p:cNvPr id="10" name="TextBox 9"/>
+          <p:cNvSpPr txBox="1"/>
+          <p:nvPr/>
+        </p:nvSpPr>
+        <p:spPr>
+          <a:xfrm>
+            <a:off x="548640" y="6473952"/>
+            <a:ext cx="8229600" cy="274320"/>
+          </a:xfrm>
+          <a:prstGeom prst="rect">
+            <a:avLst/>
+          </a:prstGeom>
+          <a:noFill/>
+        </p:spPr>
+        <p:txBody>
+          <a:bodyPr wrap="square" anchor="t">
+            <a:spAutoFit/>
+          </a:bodyPr>
+          <a:lstStyle/>
+          <a:p>
+            <a:pPr algn="l">
+              <a:lnSpc>
+                <a:spcPct val="100000"/>
+              </a:lnSpc>
+              <a:spcBef>
+                <a:spcPts val="0"/>
+              </a:spcBef>
+              <a:spcAft>
+                <a:spcPts val="400"/>
+              </a:spcAft>
+            </a:pPr>
+            <a:r>
+              <a:rPr sz="900" b="0">
+                <a:solidFill>
+                  <a:srgbClr val="5A6672"/>
+                </a:solidFill>
+                <a:latin typeface="Tahoma"/>
+                <a:cs typeface="Tahoma"/>
+                <a:ea typeface="Tahoma"/>
+              </a:rPr>
+              <a:t>TANACHOK — ระบบงานสลากธนโชค</a:t>
+            </a:r>
+          </a:p>
+        </p:txBody>
+      </p:sp>
+      <p:sp>
+        <p:nvSpPr>
+          <p:cNvPr id="11" name="TextBox 10"/>
+          <p:cNvSpPr txBox="1"/>
+          <p:nvPr/>
+        </p:nvSpPr>
+        <p:spPr>
+          <a:xfrm>
+            <a:off x="10972800" y="6473952"/>
+            <a:ext cx="822960" cy="274320"/>
+          </a:xfrm>
+          <a:prstGeom prst="rect">
+            <a:avLst/>
+          </a:prstGeom>
+          <a:noFill/>
+        </p:spPr>
+        <p:txBody>
+          <a:bodyPr wrap="square" anchor="t">
+            <a:spAutoFit/>
+          </a:bodyPr>
+          <a:lstStyle/>
+          <a:p>
+            <a:pPr algn="r">
+              <a:lnSpc>
+                <a:spcPct val="100000"/>
+              </a:lnSpc>
+              <a:spcBef>
+                <a:spcPts val="0"/>
+              </a:spcBef>
+              <a:spcAft>
+                <a:spcPts val="400"/>
+              </a:spcAft>
+            </a:pPr>
+            <a:r>
+              <a:rPr sz="900" b="0">
+                <a:solidFill>
+                  <a:srgbClr val="5A6672"/>
+                </a:solidFill>
+                <a:latin typeface="Tahoma"/>
+                <a:cs typeface="Tahoma"/>
+                <a:ea typeface="Tahoma"/>
+              </a:rPr>
+              <a:t>11</a:t>
+            </a:r>
+          </a:p>
+        </p:txBody>
+      </p:sp>
+    </p:spTree>
+  </p:cSld>
+  <p:clrMapOvr>
+    <a:masterClrMapping/>
+  </p:clrMapOvr>
+</p:sld>
+</file>
+
+<file path=ppt/slides/slide12.xml><?xml version="1.0" encoding="utf-8"?>
+<p:sld xmlns:a="http://schemas.openxmlformats.org/drawingml/2006/main" xmlns:p="http://schemas.openxmlformats.org/presentationml/2006/main" xmlns:r="http://schemas.openxmlformats.org/officeDocument/2006/relationships">
+  <p:cSld>
+    <p:spTree>
+      <p:nvGrpSpPr>
+        <p:cNvPr id="1" name=""/>
+        <p:cNvGrpSpPr/>
+        <p:nvPr/>
+      </p:nvGrpSpPr>
+      <p:grpSpPr/>
+      <p:sp>
+        <p:nvSpPr>
+          <p:cNvPr id="2" name="Rectangle 1"/>
+          <p:cNvSpPr/>
+          <p:nvPr/>
+        </p:nvSpPr>
+        <p:spPr>
+          <a:xfrm>
+            <a:off x="0" y="0"/>
+            <a:ext cx="12191695" cy="6858000"/>
+          </a:xfrm>
+          <a:prstGeom prst="rect">
+            <a:avLst/>
+          </a:prstGeom>
+          <a:solidFill>
+            <a:srgbClr val="FFFFFF"/>
+          </a:solidFill>
+          <a:ln>
+            <a:noFill/>
+          </a:ln>
+          <a:effectLst/>
+        </p:spPr>
+        <p:style>
+          <a:lnRef idx="1">
+            <a:schemeClr val="accent1"/>
+          </a:lnRef>
+          <a:fillRef idx="3">
+            <a:schemeClr val="accent1"/>
+          </a:fillRef>
+          <a:effectRef idx="2">
+            <a:schemeClr val="accent1"/>
+          </a:effectRef>
+          <a:fontRef idx="minor">
+            <a:schemeClr val="lt1"/>
+          </a:fontRef>
+        </p:style>
+        <p:txBody>
+          <a:bodyPr rtlCol="0" anchor="ctr"/>
+          <a:lstStyle/>
+          <a:p>
+            <a:pPr algn="ctr"/>
+          </a:p>
+        </p:txBody>
+      </p:sp>
+      <p:sp>
+        <p:nvSpPr>
+          <p:cNvPr id="3" name="Rectangle 2"/>
+          <p:cNvSpPr/>
+          <p:nvPr/>
+        </p:nvSpPr>
+        <p:spPr>
+          <a:xfrm>
+            <a:off x="0" y="0"/>
+            <a:ext cx="12191695" cy="1051560"/>
+          </a:xfrm>
+          <a:prstGeom prst="rect">
+            <a:avLst/>
+          </a:prstGeom>
+          <a:solidFill>
+            <a:srgbClr val="EC008C"/>
+          </a:solidFill>
+          <a:ln>
+            <a:noFill/>
+          </a:ln>
+          <a:effectLst/>
+        </p:spPr>
+        <p:style>
+          <a:lnRef idx="1">
+            <a:schemeClr val="accent1"/>
+          </a:lnRef>
+          <a:fillRef idx="3">
+            <a:schemeClr val="accent1"/>
+          </a:fillRef>
+          <a:effectRef idx="2">
+            <a:schemeClr val="accent1"/>
+          </a:effectRef>
+          <a:fontRef idx="minor">
+            <a:schemeClr val="lt1"/>
+          </a:fontRef>
+        </p:style>
+        <p:txBody>
+          <a:bodyPr rtlCol="0" anchor="ctr"/>
+          <a:lstStyle/>
+          <a:p>
+            <a:pPr algn="ctr"/>
+          </a:p>
+        </p:txBody>
+      </p:sp>
+      <p:sp>
+        <p:nvSpPr>
+          <p:cNvPr id="4" name="Rectangle 3"/>
+          <p:cNvSpPr/>
+          <p:nvPr/>
+        </p:nvSpPr>
+        <p:spPr>
+          <a:xfrm>
+            <a:off x="0" y="1051560"/>
+            <a:ext cx="12191695" cy="64008"/>
+          </a:xfrm>
+          <a:prstGeom prst="rect">
+            <a:avLst/>
+          </a:prstGeom>
+          <a:solidFill>
+            <a:srgbClr val="B3006A"/>
+          </a:solidFill>
+          <a:ln>
+            <a:noFill/>
+          </a:ln>
+          <a:effectLst/>
+        </p:spPr>
+        <p:style>
+          <a:lnRef idx="1">
+            <a:schemeClr val="accent1"/>
+          </a:lnRef>
+          <a:fillRef idx="3">
+            <a:schemeClr val="accent1"/>
+          </a:fillRef>
+          <a:effectRef idx="2">
+            <a:schemeClr val="accent1"/>
+          </a:effectRef>
+          <a:fontRef idx="minor">
+            <a:schemeClr val="lt1"/>
+          </a:fontRef>
+        </p:style>
+        <p:txBody>
+          <a:bodyPr rtlCol="0" anchor="ctr"/>
+          <a:lstStyle/>
+          <a:p>
+            <a:pPr algn="ctr"/>
+          </a:p>
+        </p:txBody>
+      </p:sp>
+      <p:sp>
+        <p:nvSpPr>
+          <p:cNvPr id="5" name="TextBox 4"/>
+          <p:cNvSpPr txBox="1"/>
+          <p:nvPr/>
+        </p:nvSpPr>
+        <p:spPr>
+          <a:xfrm>
+            <a:off x="548640" y="146304"/>
+            <a:ext cx="10972800" cy="411480"/>
+          </a:xfrm>
+          <a:prstGeom prst="rect">
+            <a:avLst/>
+          </a:prstGeom>
+          <a:noFill/>
+        </p:spPr>
+        <p:txBody>
+          <a:bodyPr wrap="square" anchor="t">
+            <a:spAutoFit/>
+          </a:bodyPr>
+          <a:lstStyle/>
+          <a:p>
+            <a:pPr algn="l">
+              <a:lnSpc>
+                <a:spcPct val="100000"/>
+              </a:lnSpc>
+              <a:spcBef>
+                <a:spcPts val="0"/>
+              </a:spcBef>
+              <a:spcAft>
+                <a:spcPts val="400"/>
+              </a:spcAft>
+            </a:pPr>
+            <a:r>
+              <a:rPr sz="1200" b="1">
+                <a:solidFill>
+                  <a:srgbClr val="FFD6EC"/>
+                </a:solidFill>
+                <a:latin typeface="Tahoma"/>
+                <a:cs typeface="Tahoma"/>
+                <a:ea typeface="Tahoma"/>
+              </a:rPr>
+              <a:t>ตัวอย่างหน้าจอที่เสนอ</a:t>
+            </a:r>
+          </a:p>
+        </p:txBody>
+      </p:sp>
+      <p:sp>
+        <p:nvSpPr>
+          <p:cNvPr id="6" name="TextBox 5"/>
+          <p:cNvSpPr txBox="1"/>
+          <p:nvPr/>
+        </p:nvSpPr>
+        <p:spPr>
+          <a:xfrm>
+            <a:off x="548640" y="420624"/>
+            <a:ext cx="10972800" cy="548640"/>
+          </a:xfrm>
+          <a:prstGeom prst="rect">
+            <a:avLst/>
+          </a:prstGeom>
+          <a:noFill/>
+        </p:spPr>
+        <p:txBody>
+          <a:bodyPr wrap="square" anchor="t">
+            <a:spAutoFit/>
+          </a:bodyPr>
+          <a:lstStyle/>
+          <a:p>
+            <a:pPr algn="l">
+              <a:lnSpc>
+                <a:spcPct val="100000"/>
+              </a:lnSpc>
+              <a:spcBef>
+                <a:spcPts val="0"/>
+              </a:spcBef>
+              <a:spcAft>
+                <a:spcPts val="400"/>
+              </a:spcAft>
+            </a:pPr>
+            <a:r>
+              <a:rPr sz="2500" b="1">
+                <a:solidFill>
+                  <a:srgbClr val="FFFFFF"/>
+                </a:solidFill>
+                <a:latin typeface="Tahoma"/>
+                <a:cs typeface="Tahoma"/>
+                <a:ea typeface="Tahoma"/>
+              </a:rPr>
+              <a:t>หน้าจอ 3 · การส่งข้อมูลออก (SFTP Feed)</a:t>
+            </a:r>
+          </a:p>
+        </p:txBody>
+      </p:sp>
+      <p:sp>
+        <p:nvSpPr>
+          <p:cNvPr id="7" name="TextBox 6"/>
+          <p:cNvSpPr txBox="1"/>
+          <p:nvPr/>
+        </p:nvSpPr>
+        <p:spPr>
+          <a:xfrm>
+            <a:off x="548640" y="1207008"/>
+            <a:ext cx="11091672" cy="329184"/>
+          </a:xfrm>
+          <a:prstGeom prst="rect">
+            <a:avLst/>
+          </a:prstGeom>
+          <a:noFill/>
+        </p:spPr>
+        <p:txBody>
+          <a:bodyPr wrap="square" anchor="t">
+            <a:spAutoFit/>
+          </a:bodyPr>
+          <a:lstStyle/>
+          <a:p>
+            <a:pPr algn="l">
+              <a:lnSpc>
+                <a:spcPct val="100000"/>
+              </a:lnSpc>
+              <a:spcBef>
+                <a:spcPts val="0"/>
+              </a:spcBef>
+              <a:spcAft>
+                <a:spcPts val="400"/>
+              </a:spcAft>
+            </a:pPr>
+            <a:r>
+              <a:rPr sz="1250" b="0">
+                <a:solidFill>
+                  <a:srgbClr val="5A6672"/>
+                </a:solidFill>
+                <a:latin typeface="Tahoma"/>
+                <a:cs typeface="Tahoma"/>
+                <a:ea typeface="Tahoma"/>
+              </a:rPr>
+              <a:t>เห็นผลการส่งทุกรอบ รู้ทันทีเมื่อไม่สำเร็จ ส่งซ้ำได้เอง และตั้งการแจ้งเตือนได้</a:t>
+            </a:r>
+          </a:p>
+        </p:txBody>
+      </p:sp>
+      <p:pic>
+        <p:nvPicPr>
+          <p:cNvPr id="8" name="Picture 7" descr="screen3-feed.png"/>
+          <p:cNvPicPr>
+            <a:picLocks noChangeAspect="1"/>
+          </p:cNvPicPr>
+          <p:nvPr/>
+        </p:nvPicPr>
+        <p:blipFill>
+          <a:blip r:embed="rId2"/>
+          <a:stretch>
+            <a:fillRect/>
+          </a:stretch>
+        </p:blipFill>
+        <p:spPr>
+          <a:xfrm>
+            <a:off x="548640" y="1627632"/>
+            <a:ext cx="11091672" cy="6932295"/>
+          </a:xfrm>
+          <a:prstGeom prst="rect">
+            <a:avLst/>
+          </a:prstGeom>
+        </p:spPr>
+      </p:pic>
+      <p:sp>
+        <p:nvSpPr>
+          <p:cNvPr id="9" name="TextBox 8"/>
+          <p:cNvSpPr txBox="1"/>
+          <p:nvPr/>
+        </p:nvSpPr>
+        <p:spPr>
+          <a:xfrm>
+            <a:off x="548640" y="6355080"/>
+            <a:ext cx="11091672" cy="274320"/>
+          </a:xfrm>
+          <a:prstGeom prst="rect">
+            <a:avLst/>
+          </a:prstGeom>
+          <a:noFill/>
+        </p:spPr>
+        <p:txBody>
+          <a:bodyPr wrap="square" anchor="t">
+            <a:spAutoFit/>
+          </a:bodyPr>
+          <a:lstStyle/>
+          <a:p>
+            <a:pPr algn="l">
+              <a:lnSpc>
+                <a:spcPct val="100000"/>
+              </a:lnSpc>
+              <a:spcBef>
+                <a:spcPts val="0"/>
+              </a:spcBef>
+              <a:spcAft>
+                <a:spcPts val="400"/>
+              </a:spcAft>
+            </a:pPr>
+            <a:r>
+              <a:rPr sz="1000" b="0">
+                <a:solidFill>
+                  <a:srgbClr val="5A6672"/>
+                </a:solidFill>
+                <a:latin typeface="Tahoma"/>
+                <a:cs typeface="Tahoma"/>
+                <a:ea typeface="Tahoma"/>
+              </a:rPr>
+              <a:t>ภาพร่างเพื่อใช้หารือ · ข้อมูลบนหน้าจอเป็นตัวอย่างสมมติ ไม่ใช่ข้อมูลจริงของลูกค้า</a:t>
+            </a:r>
+          </a:p>
+        </p:txBody>
+      </p:sp>
+      <p:sp>
+        <p:nvSpPr>
+          <p:cNvPr id="10" name="TextBox 9"/>
+          <p:cNvSpPr txBox="1"/>
+          <p:nvPr/>
+        </p:nvSpPr>
+        <p:spPr>
+          <a:xfrm>
+            <a:off x="548640" y="6473952"/>
+            <a:ext cx="8229600" cy="274320"/>
+          </a:xfrm>
+          <a:prstGeom prst="rect">
+            <a:avLst/>
+          </a:prstGeom>
+          <a:noFill/>
+        </p:spPr>
+        <p:txBody>
+          <a:bodyPr wrap="square" anchor="t">
+            <a:spAutoFit/>
+          </a:bodyPr>
+          <a:lstStyle/>
+          <a:p>
+            <a:pPr algn="l">
+              <a:lnSpc>
+                <a:spcPct val="100000"/>
+              </a:lnSpc>
+              <a:spcBef>
+                <a:spcPts val="0"/>
+              </a:spcBef>
+              <a:spcAft>
+                <a:spcPts val="400"/>
+              </a:spcAft>
+            </a:pPr>
+            <a:r>
+              <a:rPr sz="900" b="0">
+                <a:solidFill>
+                  <a:srgbClr val="5A6672"/>
+                </a:solidFill>
+                <a:latin typeface="Tahoma"/>
+                <a:cs typeface="Tahoma"/>
+                <a:ea typeface="Tahoma"/>
+              </a:rPr>
+              <a:t>TANACHOK — ระบบงานสลากธนโชค</a:t>
+            </a:r>
+          </a:p>
+        </p:txBody>
+      </p:sp>
+      <p:sp>
+        <p:nvSpPr>
+          <p:cNvPr id="11" name="TextBox 10"/>
+          <p:cNvSpPr txBox="1"/>
+          <p:nvPr/>
+        </p:nvSpPr>
+        <p:spPr>
+          <a:xfrm>
+            <a:off x="10972800" y="6473952"/>
+            <a:ext cx="822960" cy="274320"/>
+          </a:xfrm>
+          <a:prstGeom prst="rect">
+            <a:avLst/>
+          </a:prstGeom>
+          <a:noFill/>
+        </p:spPr>
+        <p:txBody>
+          <a:bodyPr wrap="square" anchor="t">
+            <a:spAutoFit/>
+          </a:bodyPr>
+          <a:lstStyle/>
+          <a:p>
+            <a:pPr algn="r">
+              <a:lnSpc>
+                <a:spcPct val="100000"/>
+              </a:lnSpc>
+              <a:spcBef>
+                <a:spcPts val="0"/>
+              </a:spcBef>
+              <a:spcAft>
+                <a:spcPts val="400"/>
+              </a:spcAft>
+            </a:pPr>
+            <a:r>
+              <a:rPr sz="900" b="0">
+                <a:solidFill>
+                  <a:srgbClr val="5A6672"/>
+                </a:solidFill>
+                <a:latin typeface="Tahoma"/>
+                <a:cs typeface="Tahoma"/>
+                <a:ea typeface="Tahoma"/>
+              </a:rPr>
+              <a:t>12</a:t>
+            </a:r>
+          </a:p>
+        </p:txBody>
+      </p:sp>
+    </p:spTree>
+  </p:cSld>
+  <p:clrMapOvr>
+    <a:masterClrMapping/>
+  </p:clrMapOvr>
+</p:sld>
+</file>
+
+<file path=ppt/slides/slide13.xml><?xml version="1.0" encoding="utf-8"?>
+<p:sld xmlns:a="http://schemas.openxmlformats.org/drawingml/2006/main" xmlns:p="http://schemas.openxmlformats.org/presentationml/2006/main" xmlns:r="http://schemas.openxmlformats.org/officeDocument/2006/relationships">
+  <p:cSld>
+    <p:spTree>
+      <p:nvGrpSpPr>
+        <p:cNvPr id="1" name=""/>
+        <p:cNvGrpSpPr/>
+        <p:nvPr/>
+      </p:nvGrpSpPr>
+      <p:grpSpPr/>
+      <p:sp>
+        <p:nvSpPr>
+          <p:cNvPr id="2" name="Rectangle 1"/>
+          <p:cNvSpPr/>
+          <p:nvPr/>
+        </p:nvSpPr>
+        <p:spPr>
+          <a:xfrm>
+            <a:off x="0" y="0"/>
+            <a:ext cx="12191695" cy="6858000"/>
+          </a:xfrm>
+          <a:prstGeom prst="rect">
+            <a:avLst/>
+          </a:prstGeom>
+          <a:solidFill>
+            <a:srgbClr val="FFFFFF"/>
+          </a:solidFill>
+          <a:ln>
+            <a:noFill/>
+          </a:ln>
+          <a:effectLst/>
+        </p:spPr>
+        <p:style>
+          <a:lnRef idx="1">
+            <a:schemeClr val="accent1"/>
+          </a:lnRef>
+          <a:fillRef idx="3">
+            <a:schemeClr val="accent1"/>
+          </a:fillRef>
+          <a:effectRef idx="2">
+            <a:schemeClr val="accent1"/>
+          </a:effectRef>
+          <a:fontRef idx="minor">
+            <a:schemeClr val="lt1"/>
+          </a:fontRef>
+        </p:style>
+        <p:txBody>
+          <a:bodyPr rtlCol="0" anchor="ctr"/>
+          <a:lstStyle/>
+          <a:p>
+            <a:pPr algn="ctr"/>
+          </a:p>
+        </p:txBody>
+      </p:sp>
+      <p:sp>
+        <p:nvSpPr>
+          <p:cNvPr id="3" name="Rectangle 2"/>
+          <p:cNvSpPr/>
+          <p:nvPr/>
+        </p:nvSpPr>
+        <p:spPr>
+          <a:xfrm>
+            <a:off x="0" y="0"/>
+            <a:ext cx="12191695" cy="1051560"/>
+          </a:xfrm>
+          <a:prstGeom prst="rect">
+            <a:avLst/>
+          </a:prstGeom>
+          <a:solidFill>
+            <a:srgbClr val="EC008C"/>
+          </a:solidFill>
+          <a:ln>
+            <a:noFill/>
+          </a:ln>
+          <a:effectLst/>
+        </p:spPr>
+        <p:style>
+          <a:lnRef idx="1">
+            <a:schemeClr val="accent1"/>
+          </a:lnRef>
+          <a:fillRef idx="3">
+            <a:schemeClr val="accent1"/>
+          </a:fillRef>
+          <a:effectRef idx="2">
+            <a:schemeClr val="accent1"/>
+          </a:effectRef>
+          <a:fontRef idx="minor">
+            <a:schemeClr val="lt1"/>
+          </a:fontRef>
+        </p:style>
+        <p:txBody>
+          <a:bodyPr rtlCol="0" anchor="ctr"/>
+          <a:lstStyle/>
+          <a:p>
+            <a:pPr algn="ctr"/>
+          </a:p>
+        </p:txBody>
+      </p:sp>
+      <p:sp>
+        <p:nvSpPr>
+          <p:cNvPr id="4" name="Rectangle 3"/>
+          <p:cNvSpPr/>
+          <p:nvPr/>
+        </p:nvSpPr>
+        <p:spPr>
+          <a:xfrm>
+            <a:off x="0" y="1051560"/>
+            <a:ext cx="12191695" cy="64008"/>
+          </a:xfrm>
+          <a:prstGeom prst="rect">
+            <a:avLst/>
+          </a:prstGeom>
+          <a:solidFill>
+            <a:srgbClr val="B3006A"/>
+          </a:solidFill>
+          <a:ln>
+            <a:noFill/>
+          </a:ln>
+          <a:effectLst/>
+        </p:spPr>
+        <p:style>
+          <a:lnRef idx="1">
+            <a:schemeClr val="accent1"/>
+          </a:lnRef>
+          <a:fillRef idx="3">
+            <a:schemeClr val="accent1"/>
+          </a:fillRef>
+          <a:effectRef idx="2">
+            <a:schemeClr val="accent1"/>
+          </a:effectRef>
+          <a:fontRef idx="minor">
+            <a:schemeClr val="lt1"/>
+          </a:fontRef>
+        </p:style>
+        <p:txBody>
+          <a:bodyPr rtlCol="0" anchor="ctr"/>
+          <a:lstStyle/>
+          <a:p>
+            <a:pPr algn="ctr"/>
+          </a:p>
+        </p:txBody>
+      </p:sp>
+      <p:sp>
+        <p:nvSpPr>
+          <p:cNvPr id="5" name="TextBox 4"/>
+          <p:cNvSpPr txBox="1"/>
+          <p:nvPr/>
+        </p:nvSpPr>
+        <p:spPr>
+          <a:xfrm>
+            <a:off x="548640" y="146304"/>
+            <a:ext cx="10972800" cy="411480"/>
+          </a:xfrm>
+          <a:prstGeom prst="rect">
+            <a:avLst/>
+          </a:prstGeom>
+          <a:noFill/>
+        </p:spPr>
+        <p:txBody>
+          <a:bodyPr wrap="square" anchor="t">
+            <a:spAutoFit/>
+          </a:bodyPr>
+          <a:lstStyle/>
+          <a:p>
+            <a:pPr algn="l">
+              <a:lnSpc>
+                <a:spcPct val="100000"/>
+              </a:lnSpc>
+              <a:spcBef>
+                <a:spcPts val="0"/>
+              </a:spcBef>
+              <a:spcAft>
+                <a:spcPts val="400"/>
+              </a:spcAft>
+            </a:pPr>
+            <a:r>
+              <a:rPr sz="1200" b="1">
+                <a:solidFill>
+                  <a:srgbClr val="FFD6EC"/>
+                </a:solidFill>
+                <a:latin typeface="Tahoma"/>
+                <a:cs typeface="Tahoma"/>
+                <a:ea typeface="Tahoma"/>
+              </a:rPr>
+              <a:t>ตัวอย่างให้เห็นภาพ</a:t>
+            </a:r>
+          </a:p>
+        </p:txBody>
+      </p:sp>
+      <p:sp>
+        <p:nvSpPr>
+          <p:cNvPr id="6" name="TextBox 5"/>
+          <p:cNvSpPr txBox="1"/>
+          <p:nvPr/>
+        </p:nvSpPr>
+        <p:spPr>
+          <a:xfrm>
+            <a:off x="548640" y="420624"/>
+            <a:ext cx="10972800" cy="548640"/>
+          </a:xfrm>
+          <a:prstGeom prst="rect">
+            <a:avLst/>
+          </a:prstGeom>
+          <a:noFill/>
+        </p:spPr>
+        <p:txBody>
+          <a:bodyPr wrap="square" anchor="t">
+            <a:spAutoFit/>
+          </a:bodyPr>
+          <a:lstStyle/>
+          <a:p>
+            <a:pPr algn="l">
+              <a:lnSpc>
+                <a:spcPct val="100000"/>
+              </a:lnSpc>
+              <a:spcBef>
+                <a:spcPts val="0"/>
+              </a:spcBef>
+              <a:spcAft>
+                <a:spcPts val="400"/>
+              </a:spcAft>
+            </a:pPr>
+            <a:r>
+              <a:rPr sz="2500" b="1">
+                <a:solidFill>
+                  <a:srgbClr val="FFFFFF"/>
+                </a:solidFill>
+                <a:latin typeface="Tahoma"/>
+                <a:cs typeface="Tahoma"/>
+                <a:ea typeface="Tahoma"/>
+              </a:rPr>
+              <a:t>สรุปหน้าจอที่เสนอทั้งหมด</a:t>
+            </a:r>
+          </a:p>
+        </p:txBody>
+      </p:sp>
+      <p:sp>
+        <p:nvSpPr>
+          <p:cNvPr id="7" name="TextBox 6"/>
+          <p:cNvSpPr txBox="1"/>
+          <p:nvPr/>
+        </p:nvSpPr>
+        <p:spPr>
+          <a:xfrm>
+            <a:off x="548640" y="1280160"/>
+            <a:ext cx="11064240" cy="640080"/>
+          </a:xfrm>
+          <a:prstGeom prst="rect">
+            <a:avLst/>
+          </a:prstGeom>
+          <a:noFill/>
+        </p:spPr>
+        <p:txBody>
+          <a:bodyPr wrap="square" anchor="t">
+            <a:spAutoFit/>
+          </a:bodyPr>
+          <a:lstStyle/>
+          <a:p>
+            <a:pPr algn="l">
+              <a:lnSpc>
+                <a:spcPct val="100000"/>
+              </a:lnSpc>
+              <a:spcBef>
+                <a:spcPts val="0"/>
+              </a:spcBef>
+              <a:spcAft>
+                <a:spcPts val="400"/>
+              </a:spcAft>
+            </a:pPr>
+            <a:r>
+              <a:rPr sz="1400" b="0">
+                <a:solidFill>
+                  <a:srgbClr val="5A6672"/>
+                </a:solidFill>
+                <a:latin typeface="Tahoma"/>
+                <a:cs typeface="Tahoma"/>
+                <a:ea typeface="Tahoma"/>
+              </a:rPr>
+              <a:t>ภาพร่างหน้าจอเพื่อใช้หารือ — ยังไม่ใช่ข้อสรุป ปรับได้ตามความเห็นของเจ้าของระบบ</a:t>
+            </a:r>
+          </a:p>
+        </p:txBody>
+      </p:sp>
+      <p:sp>
+        <p:nvSpPr>
+          <p:cNvPr id="8" name="Rounded Rectangle 7"/>
+          <p:cNvSpPr/>
+          <p:nvPr/>
+        </p:nvSpPr>
+        <p:spPr>
+          <a:xfrm>
+            <a:off x="548640" y="2148840"/>
+            <a:ext cx="3587496" cy="1371600"/>
+          </a:xfrm>
+          <a:prstGeom prst="roundRect">
+            <a:avLst/>
+          </a:prstGeom>
+          <a:solidFill>
+            <a:srgbClr val="F4F1F6"/>
+          </a:solidFill>
+          <a:ln w="12700">
+            <a:solidFill>
+              <a:srgbClr val="D9CED6"/>
+            </a:solidFill>
+          </a:ln>
+          <a:effectLst/>
+        </p:spPr>
+        <p:style>
+          <a:lnRef idx="1">
+            <a:schemeClr val="accent1"/>
+          </a:lnRef>
+          <a:fillRef idx="3">
+            <a:schemeClr val="accent1"/>
+          </a:fillRef>
+          <a:effectRef idx="2">
+            <a:schemeClr val="accent1"/>
+          </a:effectRef>
+          <a:fontRef idx="minor">
+            <a:schemeClr val="lt1"/>
+          </a:fontRef>
+        </p:style>
+        <p:txBody>
+          <a:bodyPr rtlCol="0" anchor="ctr"/>
+          <a:lstStyle/>
+          <a:p>
+            <a:pPr algn="ctr"/>
+          </a:p>
+        </p:txBody>
+      </p:sp>
+      <p:sp>
+        <p:nvSpPr>
+          <p:cNvPr id="9" name="Rectangle 8"/>
+          <p:cNvSpPr/>
+          <p:nvPr/>
+        </p:nvSpPr>
+        <p:spPr>
+          <a:xfrm>
+            <a:off x="548640" y="2148840"/>
+            <a:ext cx="118872" cy="1371600"/>
+          </a:xfrm>
+          <a:prstGeom prst="rect">
+            <a:avLst/>
+          </a:prstGeom>
+          <a:solidFill>
+            <a:srgbClr val="EC008C"/>
+          </a:solidFill>
+          <a:ln>
+            <a:noFill/>
+          </a:ln>
+          <a:effectLst/>
+        </p:spPr>
+        <p:style>
+          <a:lnRef idx="1">
+            <a:schemeClr val="accent1"/>
+          </a:lnRef>
+          <a:fillRef idx="3">
+            <a:schemeClr val="accent1"/>
+          </a:fillRef>
+          <a:effectRef idx="2">
+            <a:schemeClr val="accent1"/>
+          </a:effectRef>
+          <a:fontRef idx="minor">
+            <a:schemeClr val="lt1"/>
+          </a:fontRef>
+        </p:style>
+        <p:txBody>
+          <a:bodyPr rtlCol="0" anchor="ctr"/>
+          <a:lstStyle/>
+          <a:p>
+            <a:pPr algn="ctr"/>
+          </a:p>
+        </p:txBody>
+      </p:sp>
+      <p:sp>
+        <p:nvSpPr>
+          <p:cNvPr id="10" name="TextBox 9"/>
+          <p:cNvSpPr txBox="1"/>
+          <p:nvPr/>
+        </p:nvSpPr>
+        <p:spPr>
+          <a:xfrm>
+            <a:off x="804672" y="2295144"/>
+            <a:ext cx="3221736" cy="365760"/>
+          </a:xfrm>
+          <a:prstGeom prst="rect">
+            <a:avLst/>
+          </a:prstGeom>
+          <a:noFill/>
+        </p:spPr>
+        <p:txBody>
+          <a:bodyPr wrap="square" anchor="t">
+            <a:spAutoFit/>
+          </a:bodyPr>
+          <a:lstStyle/>
+          <a:p>
+            <a:pPr algn="l">
+              <a:lnSpc>
+                <a:spcPct val="100000"/>
+              </a:lnSpc>
+              <a:spcBef>
+                <a:spcPts val="0"/>
+              </a:spcBef>
+              <a:spcAft>
+                <a:spcPts val="400"/>
+              </a:spcAft>
+            </a:pPr>
+            <a:r>
+              <a:rPr sz="1600" b="1">
+                <a:solidFill>
+                  <a:srgbClr val="222B36"/>
+                </a:solidFill>
+                <a:latin typeface="Tahoma"/>
+                <a:cs typeface="Tahoma"/>
+                <a:ea typeface="Tahoma"/>
+              </a:rPr>
+              <a:t>หน้าภาพรวม</a:t>
+            </a:r>
+          </a:p>
+        </p:txBody>
+      </p:sp>
+      <p:sp>
+        <p:nvSpPr>
+          <p:cNvPr id="11" name="TextBox 10"/>
+          <p:cNvSpPr txBox="1"/>
+          <p:nvPr/>
+        </p:nvSpPr>
+        <p:spPr>
+          <a:xfrm>
+            <a:off x="804672" y="2715768"/>
+            <a:ext cx="3221736" cy="320040"/>
+          </a:xfrm>
+          <a:prstGeom prst="rect">
+            <a:avLst/>
+          </a:prstGeom>
+          <a:noFill/>
+        </p:spPr>
+        <p:txBody>
+          <a:bodyPr wrap="square" anchor="t">
+            <a:spAutoFit/>
+          </a:bodyPr>
+          <a:lstStyle/>
+          <a:p>
+            <a:pPr algn="l">
+              <a:lnSpc>
+                <a:spcPct val="100000"/>
+              </a:lnSpc>
+              <a:spcBef>
+                <a:spcPts val="0"/>
+              </a:spcBef>
+              <a:spcAft>
+                <a:spcPts val="400"/>
+              </a:spcAft>
+            </a:pPr>
+            <a:r>
+              <a:rPr sz="1250" b="1">
+                <a:solidFill>
+                  <a:srgbClr val="B3006A"/>
+                </a:solidFill>
+                <a:latin typeface="Tahoma"/>
+                <a:cs typeface="Tahoma"/>
+                <a:ea typeface="Tahoma"/>
+              </a:rPr>
+              <a:t>Dashboard</a:t>
+            </a:r>
+          </a:p>
+        </p:txBody>
+      </p:sp>
+      <p:sp>
+        <p:nvSpPr>
+          <p:cNvPr id="12" name="TextBox 11"/>
+          <p:cNvSpPr txBox="1"/>
+          <p:nvPr/>
+        </p:nvSpPr>
+        <p:spPr>
+          <a:xfrm>
+            <a:off x="804672" y="3063240"/>
+            <a:ext cx="3221736" cy="365760"/>
+          </a:xfrm>
+          <a:prstGeom prst="rect">
+            <a:avLst/>
+          </a:prstGeom>
+          <a:noFill/>
+        </p:spPr>
+        <p:txBody>
+          <a:bodyPr wrap="square" anchor="t">
+            <a:spAutoFit/>
+          </a:bodyPr>
+          <a:lstStyle/>
+          <a:p>
+            <a:pPr algn="l">
+              <a:lnSpc>
+                <a:spcPct val="105000"/>
+              </a:lnSpc>
+              <a:spcBef>
+                <a:spcPts val="0"/>
+              </a:spcBef>
+              <a:spcAft>
+                <a:spcPts val="400"/>
+              </a:spcAft>
+            </a:pPr>
+            <a:r>
+              <a:rPr sz="1200" b="0">
+                <a:solidFill>
+                  <a:srgbClr val="5A6672"/>
+                </a:solidFill>
+                <a:latin typeface="Tahoma"/>
+                <a:cs typeface="Tahoma"/>
+                <a:ea typeface="Tahoma"/>
+              </a:rPr>
+              <a:t>สรุปยอดสลาก ธุรกรรมวันนี้ สถานะงาน Feed</a:t>
+            </a:r>
+          </a:p>
+        </p:txBody>
+      </p:sp>
+      <p:sp>
+        <p:nvSpPr>
+          <p:cNvPr id="13" name="Rounded Rectangle 12"/>
+          <p:cNvSpPr/>
+          <p:nvPr/>
+        </p:nvSpPr>
+        <p:spPr>
+          <a:xfrm>
+            <a:off x="4300728" y="2148840"/>
+            <a:ext cx="3587496" cy="1371600"/>
+          </a:xfrm>
+          <a:prstGeom prst="roundRect">
+            <a:avLst/>
+          </a:prstGeom>
+          <a:solidFill>
+            <a:srgbClr val="F4F1F6"/>
+          </a:solidFill>
+          <a:ln w="12700">
+            <a:solidFill>
+              <a:srgbClr val="D9CED6"/>
+            </a:solidFill>
+          </a:ln>
+          <a:effectLst/>
+        </p:spPr>
+        <p:style>
+          <a:lnRef idx="1">
+            <a:schemeClr val="accent1"/>
+          </a:lnRef>
+          <a:fillRef idx="3">
+            <a:schemeClr val="accent1"/>
+          </a:fillRef>
+          <a:effectRef idx="2">
+            <a:schemeClr val="accent1"/>
+          </a:effectRef>
+          <a:fontRef idx="minor">
+            <a:schemeClr val="lt1"/>
+          </a:fontRef>
+        </p:style>
+        <p:txBody>
+          <a:bodyPr rtlCol="0" anchor="ctr"/>
+          <a:lstStyle/>
+          <a:p>
+            <a:pPr algn="ctr"/>
+          </a:p>
+        </p:txBody>
+      </p:sp>
+      <p:sp>
+        <p:nvSpPr>
+          <p:cNvPr id="14" name="Rectangle 13"/>
+          <p:cNvSpPr/>
+          <p:nvPr/>
+        </p:nvSpPr>
+        <p:spPr>
+          <a:xfrm>
+            <a:off x="4300728" y="2148840"/>
+            <a:ext cx="118872" cy="1371600"/>
+          </a:xfrm>
+          <a:prstGeom prst="rect">
+            <a:avLst/>
+          </a:prstGeom>
+          <a:solidFill>
+            <a:srgbClr val="234D80"/>
+          </a:solidFill>
+          <a:ln>
+            <a:noFill/>
+          </a:ln>
+          <a:effectLst/>
+        </p:spPr>
+        <p:style>
+          <a:lnRef idx="1">
+            <a:schemeClr val="accent1"/>
+          </a:lnRef>
+          <a:fillRef idx="3">
+            <a:schemeClr val="accent1"/>
+          </a:fillRef>
+          <a:effectRef idx="2">
+            <a:schemeClr val="accent1"/>
+          </a:effectRef>
+          <a:fontRef idx="minor">
+            <a:schemeClr val="lt1"/>
+          </a:fontRef>
+        </p:style>
+        <p:txBody>
+          <a:bodyPr rtlCol="0" anchor="ctr"/>
+          <a:lstStyle/>
+          <a:p>
+            <a:pPr algn="ctr"/>
+          </a:p>
+        </p:txBody>
+      </p:sp>
+      <p:sp>
+        <p:nvSpPr>
+          <p:cNvPr id="15" name="TextBox 14"/>
+          <p:cNvSpPr txBox="1"/>
+          <p:nvPr/>
+        </p:nvSpPr>
+        <p:spPr>
+          <a:xfrm>
+            <a:off x="4556760" y="2295144"/>
+            <a:ext cx="3221736" cy="365760"/>
+          </a:xfrm>
+          <a:prstGeom prst="rect">
+            <a:avLst/>
+          </a:prstGeom>
+          <a:noFill/>
+        </p:spPr>
+        <p:txBody>
+          <a:bodyPr wrap="square" anchor="t">
+            <a:spAutoFit/>
+          </a:bodyPr>
+          <a:lstStyle/>
+          <a:p>
+            <a:pPr algn="l">
+              <a:lnSpc>
+                <a:spcPct val="100000"/>
+              </a:lnSpc>
+              <a:spcBef>
+                <a:spcPts val="0"/>
+              </a:spcBef>
+              <a:spcAft>
+                <a:spcPts val="400"/>
+              </a:spcAft>
+            </a:pPr>
+            <a:r>
+              <a:rPr sz="1600" b="1">
+                <a:solidFill>
+                  <a:srgbClr val="222B36"/>
+                </a:solidFill>
+                <a:latin typeface="Tahoma"/>
+                <a:cs typeface="Tahoma"/>
+                <a:ea typeface="Tahoma"/>
+              </a:rPr>
+              <a:t>ค้นหาผู้ถือสลาก</a:t>
+            </a:r>
+          </a:p>
+        </p:txBody>
+      </p:sp>
+      <p:sp>
+        <p:nvSpPr>
+          <p:cNvPr id="16" name="TextBox 15"/>
+          <p:cNvSpPr txBox="1"/>
+          <p:nvPr/>
+        </p:nvSpPr>
+        <p:spPr>
+          <a:xfrm>
+            <a:off x="4556760" y="2715768"/>
+            <a:ext cx="3221736" cy="320040"/>
+          </a:xfrm>
+          <a:prstGeom prst="rect">
+            <a:avLst/>
+          </a:prstGeom>
+          <a:noFill/>
+        </p:spPr>
+        <p:txBody>
+          <a:bodyPr wrap="square" anchor="t">
+            <a:spAutoFit/>
+          </a:bodyPr>
+          <a:lstStyle/>
+          <a:p>
+            <a:pPr algn="l">
+              <a:lnSpc>
+                <a:spcPct val="100000"/>
+              </a:lnSpc>
+              <a:spcBef>
+                <a:spcPts val="0"/>
+              </a:spcBef>
+              <a:spcAft>
+                <a:spcPts val="400"/>
+              </a:spcAft>
+            </a:pPr>
+            <a:r>
+              <a:rPr sz="1250" b="1">
+                <a:solidFill>
+                  <a:srgbClr val="B3006A"/>
+                </a:solidFill>
+                <a:latin typeface="Tahoma"/>
+                <a:cs typeface="Tahoma"/>
+                <a:ea typeface="Tahoma"/>
+              </a:rPr>
+              <a:t>ค้นหา/ตรวจสอบ</a:t>
+            </a:r>
+          </a:p>
+        </p:txBody>
+      </p:sp>
+      <p:sp>
+        <p:nvSpPr>
+          <p:cNvPr id="17" name="TextBox 16"/>
+          <p:cNvSpPr txBox="1"/>
+          <p:nvPr/>
+        </p:nvSpPr>
+        <p:spPr>
+          <a:xfrm>
+            <a:off x="4556760" y="3063240"/>
+            <a:ext cx="3221736" cy="365760"/>
+          </a:xfrm>
+          <a:prstGeom prst="rect">
+            <a:avLst/>
+          </a:prstGeom>
+          <a:noFill/>
+        </p:spPr>
+        <p:txBody>
+          <a:bodyPr wrap="square" anchor="t">
+            <a:spAutoFit/>
+          </a:bodyPr>
+          <a:lstStyle/>
+          <a:p>
+            <a:pPr algn="l">
+              <a:lnSpc>
+                <a:spcPct val="105000"/>
+              </a:lnSpc>
+              <a:spcBef>
+                <a:spcPts val="0"/>
+              </a:spcBef>
+              <a:spcAft>
+                <a:spcPts val="400"/>
+              </a:spcAft>
+            </a:pPr>
+            <a:r>
+              <a:rPr sz="1200" b="0">
+                <a:solidFill>
+                  <a:srgbClr val="5A6672"/>
+                </a:solidFill>
+                <a:latin typeface="Tahoma"/>
+                <a:cs typeface="Tahoma"/>
+                <a:ea typeface="Tahoma"/>
+              </a:rPr>
+              <a:t>ค้นด้วยเลขที่สลาก เลขบัตร หรือชื่อลูกค้า</a:t>
+            </a:r>
+          </a:p>
+        </p:txBody>
+      </p:sp>
+      <p:sp>
+        <p:nvSpPr>
+          <p:cNvPr id="18" name="Rounded Rectangle 17"/>
+          <p:cNvSpPr/>
+          <p:nvPr/>
+        </p:nvSpPr>
+        <p:spPr>
+          <a:xfrm>
+            <a:off x="8052816" y="2148840"/>
+            <a:ext cx="3587496" cy="1371600"/>
+          </a:xfrm>
+          <a:prstGeom prst="roundRect">
+            <a:avLst/>
+          </a:prstGeom>
+          <a:solidFill>
+            <a:srgbClr val="F4F1F6"/>
+          </a:solidFill>
+          <a:ln w="12700">
+            <a:solidFill>
+              <a:srgbClr val="D9CED6"/>
+            </a:solidFill>
+          </a:ln>
+          <a:effectLst/>
+        </p:spPr>
+        <p:style>
+          <a:lnRef idx="1">
+            <a:schemeClr val="accent1"/>
+          </a:lnRef>
+          <a:fillRef idx="3">
+            <a:schemeClr val="accent1"/>
+          </a:fillRef>
+          <a:effectRef idx="2">
+            <a:schemeClr val="accent1"/>
+          </a:effectRef>
+          <a:fontRef idx="minor">
+            <a:schemeClr val="lt1"/>
+          </a:fontRef>
+        </p:style>
+        <p:txBody>
+          <a:bodyPr rtlCol="0" anchor="ctr"/>
+          <a:lstStyle/>
+          <a:p>
+            <a:pPr algn="ctr"/>
+          </a:p>
+        </p:txBody>
+      </p:sp>
+      <p:sp>
+        <p:nvSpPr>
+          <p:cNvPr id="19" name="Rectangle 18"/>
+          <p:cNvSpPr/>
+          <p:nvPr/>
+        </p:nvSpPr>
+        <p:spPr>
+          <a:xfrm>
+            <a:off x="8052816" y="2148840"/>
+            <a:ext cx="118872" cy="1371600"/>
+          </a:xfrm>
+          <a:prstGeom prst="rect">
+            <a:avLst/>
+          </a:prstGeom>
+          <a:solidFill>
+            <a:srgbClr val="B98612"/>
+          </a:solidFill>
+          <a:ln>
+            <a:noFill/>
+          </a:ln>
+          <a:effectLst/>
+        </p:spPr>
+        <p:style>
+          <a:lnRef idx="1">
+            <a:schemeClr val="accent1"/>
+          </a:lnRef>
+          <a:fillRef idx="3">
+            <a:schemeClr val="accent1"/>
+          </a:fillRef>
+          <a:effectRef idx="2">
+            <a:schemeClr val="accent1"/>
+          </a:effectRef>
+          <a:fontRef idx="minor">
+            <a:schemeClr val="lt1"/>
+          </a:fontRef>
+        </p:style>
+        <p:txBody>
+          <a:bodyPr rtlCol="0" anchor="ctr"/>
+          <a:lstStyle/>
+          <a:p>
+            <a:pPr algn="ctr"/>
+          </a:p>
+        </p:txBody>
+      </p:sp>
+      <p:sp>
+        <p:nvSpPr>
+          <p:cNvPr id="20" name="TextBox 19"/>
+          <p:cNvSpPr txBox="1"/>
+          <p:nvPr/>
+        </p:nvSpPr>
+        <p:spPr>
+          <a:xfrm>
+            <a:off x="8308847" y="2295144"/>
+            <a:ext cx="3221736" cy="365760"/>
+          </a:xfrm>
+          <a:prstGeom prst="rect">
+            <a:avLst/>
+          </a:prstGeom>
+          <a:noFill/>
+        </p:spPr>
+        <p:txBody>
+          <a:bodyPr wrap="square" anchor="t">
+            <a:spAutoFit/>
+          </a:bodyPr>
+          <a:lstStyle/>
+          <a:p>
+            <a:pPr algn="l">
+              <a:lnSpc>
+                <a:spcPct val="100000"/>
+              </a:lnSpc>
+              <a:spcBef>
+                <a:spcPts val="0"/>
+              </a:spcBef>
+              <a:spcAft>
+                <a:spcPts val="400"/>
+              </a:spcAft>
+            </a:pPr>
+            <a:r>
+              <a:rPr sz="1600" b="1">
+                <a:solidFill>
+                  <a:srgbClr val="222B36"/>
+                </a:solidFill>
+                <a:latin typeface="Tahoma"/>
+                <a:cs typeface="Tahoma"/>
+                <a:ea typeface="Tahoma"/>
+              </a:rPr>
+              <a:t>รายละเอียดสลาก</a:t>
+            </a:r>
+          </a:p>
+        </p:txBody>
+      </p:sp>
+      <p:sp>
+        <p:nvSpPr>
+          <p:cNvPr id="21" name="TextBox 20"/>
+          <p:cNvSpPr txBox="1"/>
+          <p:nvPr/>
+        </p:nvSpPr>
+        <p:spPr>
+          <a:xfrm>
+            <a:off x="8308847" y="2715768"/>
+            <a:ext cx="3221736" cy="320040"/>
+          </a:xfrm>
+          <a:prstGeom prst="rect">
+            <a:avLst/>
+          </a:prstGeom>
+          <a:noFill/>
+        </p:spPr>
+        <p:txBody>
+          <a:bodyPr wrap="square" anchor="t">
+            <a:spAutoFit/>
+          </a:bodyPr>
+          <a:lstStyle/>
+          <a:p>
+            <a:pPr algn="l">
+              <a:lnSpc>
+                <a:spcPct val="100000"/>
+              </a:lnSpc>
+              <a:spcBef>
+                <a:spcPts val="0"/>
+              </a:spcBef>
+              <a:spcAft>
+                <a:spcPts val="400"/>
+              </a:spcAft>
+            </a:pPr>
+            <a:r>
+              <a:rPr sz="1250" b="1">
+                <a:solidFill>
+                  <a:srgbClr val="B3006A"/>
+                </a:solidFill>
+                <a:latin typeface="Tahoma"/>
+                <a:cs typeface="Tahoma"/>
+                <a:ea typeface="Tahoma"/>
+              </a:rPr>
+              <a:t>ทะเบียนสลาก</a:t>
+            </a:r>
+          </a:p>
+        </p:txBody>
+      </p:sp>
+      <p:sp>
+        <p:nvSpPr>
+          <p:cNvPr id="22" name="TextBox 21"/>
+          <p:cNvSpPr txBox="1"/>
+          <p:nvPr/>
+        </p:nvSpPr>
+        <p:spPr>
+          <a:xfrm>
+            <a:off x="8308847" y="3063240"/>
+            <a:ext cx="3221736" cy="365760"/>
+          </a:xfrm>
+          <a:prstGeom prst="rect">
+            <a:avLst/>
+          </a:prstGeom>
+          <a:noFill/>
+        </p:spPr>
+        <p:txBody>
+          <a:bodyPr wrap="square" anchor="t">
+            <a:spAutoFit/>
+          </a:bodyPr>
+          <a:lstStyle/>
+          <a:p>
+            <a:pPr algn="l">
+              <a:lnSpc>
+                <a:spcPct val="105000"/>
+              </a:lnSpc>
+              <a:spcBef>
+                <a:spcPts val="0"/>
+              </a:spcBef>
+              <a:spcAft>
+                <a:spcPts val="400"/>
+              </a:spcAft>
+            </a:pPr>
+            <a:r>
+              <a:rPr sz="1200" b="0">
+                <a:solidFill>
+                  <a:srgbClr val="5A6672"/>
+                </a:solidFill>
+                <a:latin typeface="Tahoma"/>
+                <a:cs typeface="Tahoma"/>
+                <a:ea typeface="Tahoma"/>
+              </a:rPr>
+              <a:t>ข้อมูลสลาก ประวัติธุรกรรม และผลการตรวจรางวัล</a:t>
+            </a:r>
+          </a:p>
+        </p:txBody>
+      </p:sp>
+      <p:sp>
+        <p:nvSpPr>
+          <p:cNvPr id="23" name="Rounded Rectangle 22"/>
+          <p:cNvSpPr/>
+          <p:nvPr/>
+        </p:nvSpPr>
+        <p:spPr>
+          <a:xfrm>
+            <a:off x="548640" y="3703320"/>
+            <a:ext cx="3587496" cy="1371600"/>
+          </a:xfrm>
+          <a:prstGeom prst="roundRect">
+            <a:avLst/>
+          </a:prstGeom>
+          <a:solidFill>
+            <a:srgbClr val="F4F1F6"/>
+          </a:solidFill>
+          <a:ln w="12700">
+            <a:solidFill>
+              <a:srgbClr val="D9CED6"/>
+            </a:solidFill>
+          </a:ln>
+          <a:effectLst/>
+        </p:spPr>
+        <p:style>
+          <a:lnRef idx="1">
+            <a:schemeClr val="accent1"/>
+          </a:lnRef>
+          <a:fillRef idx="3">
+            <a:schemeClr val="accent1"/>
+          </a:fillRef>
+          <a:effectRef idx="2">
+            <a:schemeClr val="accent1"/>
+          </a:effectRef>
+          <a:fontRef idx="minor">
+            <a:schemeClr val="lt1"/>
+          </a:fontRef>
+        </p:style>
+        <p:txBody>
+          <a:bodyPr rtlCol="0" anchor="ctr"/>
+          <a:lstStyle/>
+          <a:p>
+            <a:pPr algn="ctr"/>
+          </a:p>
+        </p:txBody>
+      </p:sp>
+      <p:sp>
+        <p:nvSpPr>
+          <p:cNvPr id="24" name="Rectangle 23"/>
+          <p:cNvSpPr/>
+          <p:nvPr/>
+        </p:nvSpPr>
+        <p:spPr>
+          <a:xfrm>
+            <a:off x="548640" y="3703320"/>
+            <a:ext cx="118872" cy="1371600"/>
+          </a:xfrm>
+          <a:prstGeom prst="rect">
+            <a:avLst/>
+          </a:prstGeom>
+          <a:solidFill>
+            <a:srgbClr val="2E7D46"/>
+          </a:solidFill>
+          <a:ln>
+            <a:noFill/>
+          </a:ln>
+          <a:effectLst/>
+        </p:spPr>
+        <p:style>
+          <a:lnRef idx="1">
+            <a:schemeClr val="accent1"/>
+          </a:lnRef>
+          <a:fillRef idx="3">
+            <a:schemeClr val="accent1"/>
+          </a:fillRef>
+          <a:effectRef idx="2">
+            <a:schemeClr val="accent1"/>
+          </a:effectRef>
+          <a:fontRef idx="minor">
+            <a:schemeClr val="lt1"/>
+          </a:fontRef>
+        </p:style>
+        <p:txBody>
+          <a:bodyPr rtlCol="0" anchor="ctr"/>
+          <a:lstStyle/>
+          <a:p>
+            <a:pPr algn="ctr"/>
+          </a:p>
+        </p:txBody>
+      </p:sp>
+      <p:sp>
+        <p:nvSpPr>
+          <p:cNvPr id="25" name="TextBox 24"/>
+          <p:cNvSpPr txBox="1"/>
+          <p:nvPr/>
+        </p:nvSpPr>
+        <p:spPr>
+          <a:xfrm>
+            <a:off x="804672" y="3849624"/>
+            <a:ext cx="3221736" cy="365760"/>
+          </a:xfrm>
+          <a:prstGeom prst="rect">
+            <a:avLst/>
+          </a:prstGeom>
+          <a:noFill/>
+        </p:spPr>
+        <p:txBody>
+          <a:bodyPr wrap="square" anchor="t">
+            <a:spAutoFit/>
+          </a:bodyPr>
+          <a:lstStyle/>
+          <a:p>
+            <a:pPr algn="l">
+              <a:lnSpc>
+                <a:spcPct val="100000"/>
+              </a:lnSpc>
+              <a:spcBef>
+                <a:spcPts val="0"/>
+              </a:spcBef>
+              <a:spcAft>
+                <a:spcPts val="400"/>
+              </a:spcAft>
+            </a:pPr>
+            <a:r>
+              <a:rPr sz="1600" b="1">
+                <a:solidFill>
+                  <a:srgbClr val="222B36"/>
+                </a:solidFill>
+                <a:latin typeface="Tahoma"/>
+                <a:cs typeface="Tahoma"/>
+                <a:ea typeface="Tahoma"/>
+              </a:rPr>
+              <a:t>ตรวจและจ่ายรางวัล</a:t>
+            </a:r>
+          </a:p>
+        </p:txBody>
+      </p:sp>
+      <p:sp>
+        <p:nvSpPr>
+          <p:cNvPr id="26" name="TextBox 25"/>
+          <p:cNvSpPr txBox="1"/>
+          <p:nvPr/>
+        </p:nvSpPr>
+        <p:spPr>
+          <a:xfrm>
+            <a:off x="804672" y="4270248"/>
+            <a:ext cx="3221736" cy="320040"/>
+          </a:xfrm>
+          <a:prstGeom prst="rect">
+            <a:avLst/>
+          </a:prstGeom>
+          <a:noFill/>
+        </p:spPr>
+        <p:txBody>
+          <a:bodyPr wrap="square" anchor="t">
+            <a:spAutoFit/>
+          </a:bodyPr>
+          <a:lstStyle/>
+          <a:p>
+            <a:pPr algn="l">
+              <a:lnSpc>
+                <a:spcPct val="100000"/>
+              </a:lnSpc>
+              <a:spcBef>
+                <a:spcPts val="0"/>
+              </a:spcBef>
+              <a:spcAft>
+                <a:spcPts val="400"/>
+              </a:spcAft>
+            </a:pPr>
+            <a:r>
+              <a:rPr sz="1250" b="1">
+                <a:solidFill>
+                  <a:srgbClr val="B3006A"/>
+                </a:solidFill>
+                <a:latin typeface="Tahoma"/>
+                <a:cs typeface="Tahoma"/>
+                <a:ea typeface="Tahoma"/>
+              </a:rPr>
+              <a:t>งวดรางวัล</a:t>
+            </a:r>
+          </a:p>
+        </p:txBody>
+      </p:sp>
+      <p:sp>
+        <p:nvSpPr>
+          <p:cNvPr id="27" name="TextBox 26"/>
+          <p:cNvSpPr txBox="1"/>
+          <p:nvPr/>
+        </p:nvSpPr>
+        <p:spPr>
+          <a:xfrm>
+            <a:off x="804672" y="4617720"/>
+            <a:ext cx="3221736" cy="365760"/>
+          </a:xfrm>
+          <a:prstGeom prst="rect">
+            <a:avLst/>
+          </a:prstGeom>
+          <a:noFill/>
+        </p:spPr>
+        <p:txBody>
+          <a:bodyPr wrap="square" anchor="t">
+            <a:spAutoFit/>
+          </a:bodyPr>
+          <a:lstStyle/>
+          <a:p>
+            <a:pPr algn="l">
+              <a:lnSpc>
+                <a:spcPct val="105000"/>
+              </a:lnSpc>
+              <a:spcBef>
+                <a:spcPts val="0"/>
+              </a:spcBef>
+              <a:spcAft>
+                <a:spcPts val="400"/>
+              </a:spcAft>
+            </a:pPr>
+            <a:r>
+              <a:rPr sz="1200" b="0">
+                <a:solidFill>
+                  <a:srgbClr val="5A6672"/>
+                </a:solidFill>
+                <a:latin typeface="Tahoma"/>
+                <a:cs typeface="Tahoma"/>
+                <a:ea typeface="Tahoma"/>
+              </a:rPr>
+              <a:t>ตรวจรางวัลตามงวด และบันทึกการจ่าย</a:t>
+            </a:r>
+          </a:p>
+        </p:txBody>
+      </p:sp>
+      <p:sp>
+        <p:nvSpPr>
+          <p:cNvPr id="28" name="Rounded Rectangle 27"/>
+          <p:cNvSpPr/>
+          <p:nvPr/>
+        </p:nvSpPr>
+        <p:spPr>
+          <a:xfrm>
+            <a:off x="4300728" y="3703320"/>
+            <a:ext cx="3587496" cy="1371600"/>
+          </a:xfrm>
+          <a:prstGeom prst="roundRect">
+            <a:avLst/>
+          </a:prstGeom>
+          <a:solidFill>
+            <a:srgbClr val="F4F1F6"/>
+          </a:solidFill>
+          <a:ln w="12700">
+            <a:solidFill>
+              <a:srgbClr val="D9CED6"/>
+            </a:solidFill>
+          </a:ln>
+          <a:effectLst/>
+        </p:spPr>
+        <p:style>
+          <a:lnRef idx="1">
+            <a:schemeClr val="accent1"/>
+          </a:lnRef>
+          <a:fillRef idx="3">
+            <a:schemeClr val="accent1"/>
+          </a:fillRef>
+          <a:effectRef idx="2">
+            <a:schemeClr val="accent1"/>
+          </a:effectRef>
+          <a:fontRef idx="minor">
+            <a:schemeClr val="lt1"/>
+          </a:fontRef>
+        </p:style>
+        <p:txBody>
+          <a:bodyPr rtlCol="0" anchor="ctr"/>
+          <a:lstStyle/>
+          <a:p>
+            <a:pPr algn="ctr"/>
+          </a:p>
+        </p:txBody>
+      </p:sp>
+      <p:sp>
+        <p:nvSpPr>
+          <p:cNvPr id="29" name="Rectangle 28"/>
+          <p:cNvSpPr/>
+          <p:nvPr/>
+        </p:nvSpPr>
+        <p:spPr>
+          <a:xfrm>
+            <a:off x="4300728" y="3703320"/>
+            <a:ext cx="118872" cy="1371600"/>
+          </a:xfrm>
+          <a:prstGeom prst="rect">
+            <a:avLst/>
+          </a:prstGeom>
+          <a:solidFill>
+            <a:srgbClr val="EC008C"/>
+          </a:solidFill>
+          <a:ln>
+            <a:noFill/>
+          </a:ln>
+          <a:effectLst/>
+        </p:spPr>
+        <p:style>
+          <a:lnRef idx="1">
+            <a:schemeClr val="accent1"/>
+          </a:lnRef>
+          <a:fillRef idx="3">
+            <a:schemeClr val="accent1"/>
+          </a:fillRef>
+          <a:effectRef idx="2">
+            <a:schemeClr val="accent1"/>
+          </a:effectRef>
+          <a:fontRef idx="minor">
+            <a:schemeClr val="lt1"/>
+          </a:fontRef>
+        </p:style>
+        <p:txBody>
+          <a:bodyPr rtlCol="0" anchor="ctr"/>
+          <a:lstStyle/>
+          <a:p>
+            <a:pPr algn="ctr"/>
+          </a:p>
+        </p:txBody>
+      </p:sp>
+      <p:sp>
+        <p:nvSpPr>
+          <p:cNvPr id="30" name="TextBox 29"/>
+          <p:cNvSpPr txBox="1"/>
+          <p:nvPr/>
+        </p:nvSpPr>
+        <p:spPr>
+          <a:xfrm>
+            <a:off x="4556760" y="3849624"/>
+            <a:ext cx="3221736" cy="365760"/>
+          </a:xfrm>
+          <a:prstGeom prst="rect">
+            <a:avLst/>
+          </a:prstGeom>
+          <a:noFill/>
+        </p:spPr>
+        <p:txBody>
+          <a:bodyPr wrap="square" anchor="t">
+            <a:spAutoFit/>
+          </a:bodyPr>
+          <a:lstStyle/>
+          <a:p>
+            <a:pPr algn="l">
+              <a:lnSpc>
+                <a:spcPct val="100000"/>
+              </a:lnSpc>
+              <a:spcBef>
+                <a:spcPts val="0"/>
+              </a:spcBef>
+              <a:spcAft>
+                <a:spcPts val="400"/>
+              </a:spcAft>
+            </a:pPr>
+            <a:r>
+              <a:rPr sz="1600" b="1">
+                <a:solidFill>
+                  <a:srgbClr val="222B36"/>
+                </a:solidFill>
+                <a:latin typeface="Tahoma"/>
+                <a:cs typeface="Tahoma"/>
+                <a:ea typeface="Tahoma"/>
+              </a:rPr>
+              <a:t>งานปิด/ย้ายสาขา</a:t>
+            </a:r>
+          </a:p>
+        </p:txBody>
+      </p:sp>
+      <p:sp>
+        <p:nvSpPr>
+          <p:cNvPr id="31" name="TextBox 30"/>
+          <p:cNvSpPr txBox="1"/>
+          <p:nvPr/>
+        </p:nvSpPr>
+        <p:spPr>
+          <a:xfrm>
+            <a:off x="4556760" y="4270248"/>
+            <a:ext cx="3221736" cy="320040"/>
+          </a:xfrm>
+          <a:prstGeom prst="rect">
+            <a:avLst/>
+          </a:prstGeom>
+          <a:noFill/>
+        </p:spPr>
+        <p:txBody>
+          <a:bodyPr wrap="square" anchor="t">
+            <a:spAutoFit/>
+          </a:bodyPr>
+          <a:lstStyle/>
+          <a:p>
+            <a:pPr algn="l">
+              <a:lnSpc>
+                <a:spcPct val="100000"/>
+              </a:lnSpc>
+              <a:spcBef>
+                <a:spcPts val="0"/>
+              </a:spcBef>
+              <a:spcAft>
+                <a:spcPts val="400"/>
+              </a:spcAft>
+            </a:pPr>
+            <a:r>
+              <a:rPr sz="1250" b="1">
+                <a:solidFill>
+                  <a:srgbClr val="B3006A"/>
+                </a:solidFill>
+                <a:latin typeface="Tahoma"/>
+                <a:cs typeface="Tahoma"/>
+                <a:ea typeface="Tahoma"/>
+              </a:rPr>
+              <a:t>บริหารสาขา</a:t>
+            </a:r>
+          </a:p>
+        </p:txBody>
+      </p:sp>
+      <p:sp>
+        <p:nvSpPr>
+          <p:cNvPr id="32" name="TextBox 31"/>
+          <p:cNvSpPr txBox="1"/>
+          <p:nvPr/>
+        </p:nvSpPr>
+        <p:spPr>
+          <a:xfrm>
+            <a:off x="4556760" y="4617720"/>
+            <a:ext cx="3221736" cy="365760"/>
+          </a:xfrm>
+          <a:prstGeom prst="rect">
+            <a:avLst/>
+          </a:prstGeom>
+          <a:noFill/>
+        </p:spPr>
+        <p:txBody>
+          <a:bodyPr wrap="square" anchor="t">
+            <a:spAutoFit/>
+          </a:bodyPr>
+          <a:lstStyle/>
+          <a:p>
+            <a:pPr algn="l">
+              <a:lnSpc>
+                <a:spcPct val="105000"/>
+              </a:lnSpc>
+              <a:spcBef>
+                <a:spcPts val="0"/>
+              </a:spcBef>
+              <a:spcAft>
+                <a:spcPts val="400"/>
+              </a:spcAft>
+            </a:pPr>
+            <a:r>
+              <a:rPr sz="1200" b="0">
+                <a:solidFill>
+                  <a:srgbClr val="5A6672"/>
+                </a:solidFill>
+                <a:latin typeface="Tahoma"/>
+                <a:cs typeface="Tahoma"/>
+                <a:ea typeface="Tahoma"/>
+              </a:rPr>
+              <a:t>เลือกสาขาต้นทาง–ปลายทาง ตรวจสอบก่อนยืนยัน</a:t>
+            </a:r>
+          </a:p>
+        </p:txBody>
+      </p:sp>
+      <p:sp>
+        <p:nvSpPr>
+          <p:cNvPr id="33" name="Rounded Rectangle 32"/>
+          <p:cNvSpPr/>
+          <p:nvPr/>
+        </p:nvSpPr>
+        <p:spPr>
+          <a:xfrm>
+            <a:off x="8052816" y="3703320"/>
+            <a:ext cx="3587496" cy="1371600"/>
+          </a:xfrm>
+          <a:prstGeom prst="roundRect">
+            <a:avLst/>
+          </a:prstGeom>
+          <a:solidFill>
+            <a:srgbClr val="F4F1F6"/>
+          </a:solidFill>
+          <a:ln w="12700">
+            <a:solidFill>
+              <a:srgbClr val="D9CED6"/>
+            </a:solidFill>
+          </a:ln>
+          <a:effectLst/>
+        </p:spPr>
+        <p:style>
+          <a:lnRef idx="1">
+            <a:schemeClr val="accent1"/>
+          </a:lnRef>
+          <a:fillRef idx="3">
+            <a:schemeClr val="accent1"/>
+          </a:fillRef>
+          <a:effectRef idx="2">
+            <a:schemeClr val="accent1"/>
+          </a:effectRef>
+          <a:fontRef idx="minor">
+            <a:schemeClr val="lt1"/>
+          </a:fontRef>
+        </p:style>
+        <p:txBody>
+          <a:bodyPr rtlCol="0" anchor="ctr"/>
+          <a:lstStyle/>
+          <a:p>
+            <a:pPr algn="ctr"/>
+          </a:p>
+        </p:txBody>
+      </p:sp>
+      <p:sp>
+        <p:nvSpPr>
+          <p:cNvPr id="34" name="Rectangle 33"/>
+          <p:cNvSpPr/>
+          <p:nvPr/>
+        </p:nvSpPr>
+        <p:spPr>
+          <a:xfrm>
+            <a:off x="8052816" y="3703320"/>
+            <a:ext cx="118872" cy="1371600"/>
+          </a:xfrm>
+          <a:prstGeom prst="rect">
+            <a:avLst/>
+          </a:prstGeom>
+          <a:solidFill>
+            <a:srgbClr val="234D80"/>
+          </a:solidFill>
+          <a:ln>
+            <a:noFill/>
+          </a:ln>
+          <a:effectLst/>
+        </p:spPr>
+        <p:style>
+          <a:lnRef idx="1">
+            <a:schemeClr val="accent1"/>
+          </a:lnRef>
+          <a:fillRef idx="3">
+            <a:schemeClr val="accent1"/>
+          </a:fillRef>
+          <a:effectRef idx="2">
+            <a:schemeClr val="accent1"/>
+          </a:effectRef>
+          <a:fontRef idx="minor">
+            <a:schemeClr val="lt1"/>
+          </a:fontRef>
+        </p:style>
+        <p:txBody>
+          <a:bodyPr rtlCol="0" anchor="ctr"/>
+          <a:lstStyle/>
+          <a:p>
+            <a:pPr algn="ctr"/>
+          </a:p>
+        </p:txBody>
+      </p:sp>
+      <p:sp>
+        <p:nvSpPr>
+          <p:cNvPr id="35" name="TextBox 34"/>
+          <p:cNvSpPr txBox="1"/>
+          <p:nvPr/>
+        </p:nvSpPr>
+        <p:spPr>
+          <a:xfrm>
+            <a:off x="8308847" y="3849624"/>
+            <a:ext cx="3221736" cy="365760"/>
+          </a:xfrm>
+          <a:prstGeom prst="rect">
+            <a:avLst/>
+          </a:prstGeom>
+          <a:noFill/>
+        </p:spPr>
+        <p:txBody>
+          <a:bodyPr wrap="square" anchor="t">
+            <a:spAutoFit/>
+          </a:bodyPr>
+          <a:lstStyle/>
+          <a:p>
+            <a:pPr algn="l">
+              <a:lnSpc>
+                <a:spcPct val="100000"/>
+              </a:lnSpc>
+              <a:spcBef>
+                <a:spcPts val="0"/>
+              </a:spcBef>
+              <a:spcAft>
+                <a:spcPts val="400"/>
+              </a:spcAft>
+            </a:pPr>
+            <a:r>
+              <a:rPr sz="1600" b="1">
+                <a:solidFill>
+                  <a:srgbClr val="222B36"/>
+                </a:solidFill>
+                <a:latin typeface="Tahoma"/>
+                <a:cs typeface="Tahoma"/>
+                <a:ea typeface="Tahoma"/>
+              </a:rPr>
+              <a:t>ติดตามการส่งข้อมูล</a:t>
+            </a:r>
+          </a:p>
+        </p:txBody>
+      </p:sp>
+      <p:sp>
+        <p:nvSpPr>
+          <p:cNvPr id="36" name="TextBox 35"/>
+          <p:cNvSpPr txBox="1"/>
+          <p:nvPr/>
+        </p:nvSpPr>
+        <p:spPr>
+          <a:xfrm>
+            <a:off x="8308847" y="4270248"/>
+            <a:ext cx="3221736" cy="320040"/>
+          </a:xfrm>
+          <a:prstGeom prst="rect">
+            <a:avLst/>
+          </a:prstGeom>
+          <a:noFill/>
+        </p:spPr>
+        <p:txBody>
+          <a:bodyPr wrap="square" anchor="t">
+            <a:spAutoFit/>
+          </a:bodyPr>
+          <a:lstStyle/>
+          <a:p>
+            <a:pPr algn="l">
+              <a:lnSpc>
+                <a:spcPct val="100000"/>
+              </a:lnSpc>
+              <a:spcBef>
+                <a:spcPts val="0"/>
+              </a:spcBef>
+              <a:spcAft>
+                <a:spcPts val="400"/>
+              </a:spcAft>
+            </a:pPr>
+            <a:r>
+              <a:rPr sz="1250" b="1">
+                <a:solidFill>
+                  <a:srgbClr val="B3006A"/>
+                </a:solidFill>
+                <a:latin typeface="Tahoma"/>
+                <a:cs typeface="Tahoma"/>
+                <a:ea typeface="Tahoma"/>
+              </a:rPr>
+              <a:t>SFTP Feed</a:t>
+            </a:r>
+          </a:p>
+        </p:txBody>
+      </p:sp>
+      <p:sp>
+        <p:nvSpPr>
+          <p:cNvPr id="37" name="TextBox 36"/>
+          <p:cNvSpPr txBox="1"/>
+          <p:nvPr/>
+        </p:nvSpPr>
+        <p:spPr>
+          <a:xfrm>
+            <a:off x="8308847" y="4617720"/>
+            <a:ext cx="3221736" cy="365760"/>
+          </a:xfrm>
+          <a:prstGeom prst="rect">
+            <a:avLst/>
+          </a:prstGeom>
+          <a:noFill/>
+        </p:spPr>
+        <p:txBody>
+          <a:bodyPr wrap="square" anchor="t">
+            <a:spAutoFit/>
+          </a:bodyPr>
+          <a:lstStyle/>
+          <a:p>
+            <a:pPr algn="l">
+              <a:lnSpc>
+                <a:spcPct val="105000"/>
+              </a:lnSpc>
+              <a:spcBef>
+                <a:spcPts val="0"/>
+              </a:spcBef>
+              <a:spcAft>
+                <a:spcPts val="400"/>
+              </a:spcAft>
+            </a:pPr>
+            <a:r>
+              <a:rPr sz="1200" b="0">
+                <a:solidFill>
+                  <a:srgbClr val="5A6672"/>
+                </a:solidFill>
+                <a:latin typeface="Tahoma"/>
+                <a:cs typeface="Tahoma"/>
+                <a:ea typeface="Tahoma"/>
+              </a:rPr>
+              <a:t>สถานะรอบล่าสุด ผลสำเร็จ/ล้มเหลว และปุ่มส่งซ้ำ</a:t>
+            </a:r>
+          </a:p>
+        </p:txBody>
+      </p:sp>
+      <p:sp>
+        <p:nvSpPr>
+          <p:cNvPr id="38" name="TextBox 37"/>
+          <p:cNvSpPr txBox="1"/>
+          <p:nvPr/>
+        </p:nvSpPr>
+        <p:spPr>
+          <a:xfrm>
+            <a:off x="548640" y="6473952"/>
+            <a:ext cx="8229600" cy="274320"/>
+          </a:xfrm>
+          <a:prstGeom prst="rect">
+            <a:avLst/>
+          </a:prstGeom>
+          <a:noFill/>
+        </p:spPr>
+        <p:txBody>
+          <a:bodyPr wrap="square" anchor="t">
+            <a:spAutoFit/>
+          </a:bodyPr>
+          <a:lstStyle/>
+          <a:p>
+            <a:pPr algn="l">
+              <a:lnSpc>
+                <a:spcPct val="100000"/>
+              </a:lnSpc>
+              <a:spcBef>
+                <a:spcPts val="0"/>
+              </a:spcBef>
+              <a:spcAft>
+                <a:spcPts val="400"/>
+              </a:spcAft>
+            </a:pPr>
+            <a:r>
+              <a:rPr sz="900" b="0">
+                <a:solidFill>
+                  <a:srgbClr val="5A6672"/>
+                </a:solidFill>
+                <a:latin typeface="Tahoma"/>
+                <a:cs typeface="Tahoma"/>
+                <a:ea typeface="Tahoma"/>
+              </a:rPr>
+              <a:t>TANACHOK — ระบบงานสลากธนโชค</a:t>
+            </a:r>
+          </a:p>
+        </p:txBody>
+      </p:sp>
+      <p:sp>
+        <p:nvSpPr>
+          <p:cNvPr id="39" name="TextBox 38"/>
+          <p:cNvSpPr txBox="1"/>
+          <p:nvPr/>
+        </p:nvSpPr>
+        <p:spPr>
+          <a:xfrm>
+            <a:off x="10972800" y="6473952"/>
+            <a:ext cx="822960" cy="274320"/>
+          </a:xfrm>
+          <a:prstGeom prst="rect">
+            <a:avLst/>
+          </a:prstGeom>
+          <a:noFill/>
+        </p:spPr>
+        <p:txBody>
+          <a:bodyPr wrap="square" anchor="t">
+            <a:spAutoFit/>
+          </a:bodyPr>
+          <a:lstStyle/>
+          <a:p>
+            <a:pPr algn="r">
+              <a:lnSpc>
+                <a:spcPct val="100000"/>
+              </a:lnSpc>
+              <a:spcBef>
+                <a:spcPts val="0"/>
+              </a:spcBef>
+              <a:spcAft>
+                <a:spcPts val="400"/>
+              </a:spcAft>
+            </a:pPr>
+            <a:r>
+              <a:rPr sz="900" b="0">
+                <a:solidFill>
+                  <a:srgbClr val="5A6672"/>
+                </a:solidFill>
+                <a:latin typeface="Tahoma"/>
+                <a:cs typeface="Tahoma"/>
+                <a:ea typeface="Tahoma"/>
+              </a:rPr>
+              <a:t>13</a:t>
+            </a:r>
+          </a:p>
+        </p:txBody>
+      </p:sp>
+    </p:spTree>
+  </p:cSld>
+  <p:clrMapOvr>
+    <a:masterClrMapping/>
+  </p:clrMapOvr>
+</p:sld>
+</file>
+
+<file path=ppt/slides/slide14.xml><?xml version="1.0" encoding="utf-8"?>
+<p:sld xmlns:a="http://schemas.openxmlformats.org/drawingml/2006/main" xmlns:p="http://schemas.openxmlformats.org/presentationml/2006/main" xmlns:r="http://schemas.openxmlformats.org/officeDocument/2006/relationships">
+  <p:cSld>
+    <p:spTree>
+      <p:nvGrpSpPr>
+        <p:cNvPr id="1" name=""/>
+        <p:cNvGrpSpPr/>
+        <p:nvPr/>
+      </p:nvGrpSpPr>
+      <p:grpSpPr/>
+      <p:sp>
+        <p:nvSpPr>
+          <p:cNvPr id="2" name="Rectangle 1"/>
+          <p:cNvSpPr/>
+          <p:nvPr/>
+        </p:nvSpPr>
+        <p:spPr>
+          <a:xfrm>
+            <a:off x="0" y="0"/>
+            <a:ext cx="12191695" cy="6858000"/>
+          </a:xfrm>
+          <a:prstGeom prst="rect">
+            <a:avLst/>
+          </a:prstGeom>
+          <a:solidFill>
+            <a:srgbClr val="FFFFFF"/>
+          </a:solidFill>
+          <a:ln>
+            <a:noFill/>
+          </a:ln>
+          <a:effectLst/>
+        </p:spPr>
+        <p:style>
+          <a:lnRef idx="1">
+            <a:schemeClr val="accent1"/>
+          </a:lnRef>
+          <a:fillRef idx="3">
+            <a:schemeClr val="accent1"/>
+          </a:fillRef>
+          <a:effectRef idx="2">
+            <a:schemeClr val="accent1"/>
+          </a:effectRef>
+          <a:fontRef idx="minor">
+            <a:schemeClr val="lt1"/>
+          </a:fontRef>
+        </p:style>
+        <p:txBody>
+          <a:bodyPr rtlCol="0" anchor="ctr"/>
+          <a:lstStyle/>
+          <a:p>
+            <a:pPr algn="ctr"/>
+          </a:p>
+        </p:txBody>
+      </p:sp>
+      <p:sp>
+        <p:nvSpPr>
+          <p:cNvPr id="3" name="Rectangle 2"/>
+          <p:cNvSpPr/>
+          <p:nvPr/>
+        </p:nvSpPr>
+        <p:spPr>
+          <a:xfrm>
+            <a:off x="0" y="0"/>
+            <a:ext cx="12191695" cy="1051560"/>
+          </a:xfrm>
+          <a:prstGeom prst="rect">
+            <a:avLst/>
+          </a:prstGeom>
+          <a:solidFill>
+            <a:srgbClr val="EC008C"/>
+          </a:solidFill>
+          <a:ln>
+            <a:noFill/>
+          </a:ln>
+          <a:effectLst/>
+        </p:spPr>
+        <p:style>
+          <a:lnRef idx="1">
+            <a:schemeClr val="accent1"/>
+          </a:lnRef>
+          <a:fillRef idx="3">
+            <a:schemeClr val="accent1"/>
+          </a:fillRef>
+          <a:effectRef idx="2">
+            <a:schemeClr val="accent1"/>
+          </a:effectRef>
+          <a:fontRef idx="minor">
+            <a:schemeClr val="lt1"/>
+          </a:fontRef>
+        </p:style>
+        <p:txBody>
+          <a:bodyPr rtlCol="0" anchor="ctr"/>
+          <a:lstStyle/>
+          <a:p>
+            <a:pPr algn="ctr"/>
+          </a:p>
+        </p:txBody>
+      </p:sp>
+      <p:sp>
+        <p:nvSpPr>
+          <p:cNvPr id="4" name="Rectangle 3"/>
+          <p:cNvSpPr/>
+          <p:nvPr/>
+        </p:nvSpPr>
+        <p:spPr>
+          <a:xfrm>
+            <a:off x="0" y="1051560"/>
+            <a:ext cx="12191695" cy="64008"/>
+          </a:xfrm>
+          <a:prstGeom prst="rect">
+            <a:avLst/>
+          </a:prstGeom>
+          <a:solidFill>
+            <a:srgbClr val="B3006A"/>
+          </a:solidFill>
+          <a:ln>
+            <a:noFill/>
+          </a:ln>
+          <a:effectLst/>
+        </p:spPr>
+        <p:style>
+          <a:lnRef idx="1">
+            <a:schemeClr val="accent1"/>
+          </a:lnRef>
+          <a:fillRef idx="3">
+            <a:schemeClr val="accent1"/>
+          </a:fillRef>
+          <a:effectRef idx="2">
+            <a:schemeClr val="accent1"/>
+          </a:effectRef>
+          <a:fontRef idx="minor">
+            <a:schemeClr val="lt1"/>
+          </a:fontRef>
+        </p:style>
+        <p:txBody>
+          <a:bodyPr rtlCol="0" anchor="ctr"/>
+          <a:lstStyle/>
+          <a:p>
+            <a:pPr algn="ctr"/>
+          </a:p>
+        </p:txBody>
+      </p:sp>
+      <p:sp>
+        <p:nvSpPr>
+          <p:cNvPr id="5" name="TextBox 4"/>
+          <p:cNvSpPr txBox="1"/>
+          <p:nvPr/>
+        </p:nvSpPr>
+        <p:spPr>
+          <a:xfrm>
+            <a:off x="548640" y="146304"/>
+            <a:ext cx="10972800" cy="411480"/>
+          </a:xfrm>
+          <a:prstGeom prst="rect">
+            <a:avLst/>
+          </a:prstGeom>
+          <a:noFill/>
+        </p:spPr>
+        <p:txBody>
+          <a:bodyPr wrap="square" anchor="t">
+            <a:spAutoFit/>
+          </a:bodyPr>
+          <a:lstStyle/>
+          <a:p>
+            <a:pPr algn="l">
+              <a:lnSpc>
+                <a:spcPct val="100000"/>
+              </a:lnSpc>
+              <a:spcBef>
+                <a:spcPts val="0"/>
+              </a:spcBef>
+              <a:spcAft>
+                <a:spcPts val="400"/>
+              </a:spcAft>
+            </a:pPr>
+            <a:r>
+              <a:rPr sz="1200" b="1">
+                <a:solidFill>
+                  <a:srgbClr val="FFD6EC"/>
+                </a:solidFill>
+                <a:latin typeface="Tahoma"/>
+                <a:cs typeface="Tahoma"/>
+                <a:ea typeface="Tahoma"/>
+              </a:rPr>
               <a:t>สิ่งที่ต้องการจากเจ้าของระบบ</a:t>
             </a:r>
           </a:p>
@@ -6470,7 +7841,7 @@
                 <a:cs typeface="Tahoma"/>
                 <a:ea typeface="Tahoma"/>
               </a:rPr>
-              <a:t>11</a:t>
+              <a:t>14</a:t>
             </a:r>
           </a:p>
         </p:txBody>
@@ -6483,7 +7854,7 @@
 </p:sld>
 </file>
 
-<file path=ppt/slides/slide12.xml><?xml version="1.0" encoding="utf-8"?>
+<file path=ppt/slides/slide15.xml><?xml version="1.0" encoding="utf-8"?>
 <p:sld xmlns:a="http://schemas.openxmlformats.org/drawingml/2006/main" xmlns:p="http://schemas.openxmlformats.org/presentationml/2006/main" xmlns:r="http://schemas.openxmlformats.org/officeDocument/2006/relationships">
   <p:cSld>
     <p:spTree>

</xml_diff>

<commit_message>
Rewrite review for confirmed platform migration to Linux/Docker/PostgreSQL
</commit_message>
<xml_diff>
--- a/docs/tanachok-production-slides.pptx
+++ b/docs/tanachok-production-slides.pptx
@@ -3303,7 +3303,7 @@
                 <a:cs typeface="Tahoma"/>
                 <a:ea typeface="Tahoma"/>
               </a:rPr>
-              <a:t>ทบทวนขอบเขตหลังปิดการขาย</a:t>
+              <a:t>ปิดการขาย + ย้ายแพลตฟอร์ม</a:t>
             </a:r>
           </a:p>
         </p:txBody>
@@ -4962,7 +4962,7 @@
                 <a:cs typeface="Tahoma"/>
                 <a:ea typeface="Tahoma"/>
               </a:rPr>
-              <a:t>แผนงานที่ปรับใหม่</a:t>
+              <a:t>แผนงาน 5 เฟส</a:t>
             </a:r>
           </a:p>
         </p:txBody>
@@ -5009,7 +5009,7 @@
                 <a:cs typeface="Tahoma"/>
                 <a:ea typeface="Tahoma"/>
               </a:rPr>
-              <a:t>จาก 4 เฟสเดิม เหลือ 3 เฟสที่ลดขนาดแล้ว ตัด 1 เฟส และเพิ่มเฟสปิดระบบ</a:t>
+              <a:t>หลักการ: ความปลอดภัยก่อน · ย้ายแพลตฟอร์มทีหลัง — เพราะการย้ายใช้เวลาหลายเดือนแต่ความเสี่ยงรหัสผ่านรอไม่ได้</a:t>
             </a:r>
           </a:p>
         </p:txBody>
@@ -5237,7 +5237,7 @@
                 <a:cs typeface="Tahoma"/>
                 <a:ea typeface="Tahoma"/>
               </a:rPr>
-              <a:t>ปิดความเสี่ยงเร่งด่วน · คงไว้ทั้งหมด</a:t>
+              <a:t>ปิดความเสี่ยงเร่งด่วนบนระบบเดิม · สัปดาห์ 1–2</a:t>
             </a:r>
           </a:p>
         </p:txBody>
@@ -5284,7 +5284,7 @@
                 <a:cs typeface="Tahoma"/>
                 <a:ea typeface="Tahoma"/>
               </a:rPr>
-              <a:t>เปลี่ยนรหัสผ่านทุกบัญชี · แยกบัญชีรายบุคคล · ลบรหัสออกจากเอกสาร · จำกัดการเข้าถึงเครือข่าย</a:t>
+              <a:t>เปลี่ยนรหัสผ่านทุกบัญชี · แยกบัญชีรายบุคคล · ลบรหัสออกจากเอกสาร · ปิดฟังก์ชันกลุ่ม B ก่อนย้าย</a:t>
             </a:r>
           </a:p>
         </p:txBody>
@@ -5512,7 +5512,7 @@
                 <a:cs typeface="Tahoma"/>
                 <a:ea typeface="Tahoma"/>
               </a:rPr>
-              <a:t>ทำให้ดูแลได้จริง · ลดขนาด</a:t>
+              <a:t>เตรียมจุดย้อนกลับ · สัปดาห์ 3–6</a:t>
             </a:r>
           </a:p>
         </p:txBody>
@@ -5559,7 +5559,7 @@
                 <a:cs typeface="Tahoma"/>
                 <a:ea typeface="Tahoma"/>
               </a:rPr>
-              <a:t>สำรองข้อมูล + ซ้อมกู้คืน · เฝ้าระวังเท่าที่จำเป็น · ถ้าเลิก Feed ตัดส่วนนั้นทิ้ง</a:t>
+              <a:t>สำรองข้อมูล + ซ้อมกู้คืนให้ผ่านก่อนแตะข้อมูล · เฝ้าระวังพื้นฐาน · ตัดสินใจเรื่อง Feed</a:t>
             </a:r>
           </a:p>
         </p:txBody>
@@ -5787,7 +5787,7 @@
                 <a:cs typeface="Tahoma"/>
                 <a:ea typeface="Tahoma"/>
               </a:rPr>
-              <a:t>คุมการเปลี่ยนแปลง · ลดเหลือเท่าที่จำเป็น</a:t>
+              <a:t>เตรียมย้ายแพลตฟอร์ม · สัปดาห์ 7–16</a:t>
             </a:r>
           </a:p>
         </p:txBody>
@@ -5834,7 +5834,7 @@
                 <a:cs typeface="Tahoma"/>
                 <a:ea typeface="Tahoma"/>
               </a:rPr>
-              <a:t>คุมสิทธิ์การแก้ไข · เก็บเอกสารปฏิบัติการ (ระบบแทบไม่มีการแก้ไขแล้ว)</a:t>
+              <a:t>เขียน SP ใหม่บน PostgreSQL · ย้ายข้อมูล · กระทบยอดทุกบาท · ยกประวัติธุรกรรมเดิมไปด้วย</a:t>
             </a:r>
           </a:p>
         </p:txBody>
@@ -6062,7 +6062,7 @@
                 <a:cs typeface="Tahoma"/>
                 <a:ea typeface="Tahoma"/>
               </a:rPr>
-              <a:t>ยกระดับ/พัฒนาใหม่ · ตัดออก</a:t>
+              <a:t>รันคู่ขนานและ Cutover</a:t>
             </a:r>
           </a:p>
         </p:txBody>
@@ -6109,7 +6109,7 @@
                 <a:cs typeface="Tahoma"/>
                 <a:ea typeface="Tahoma"/>
               </a:rPr>
-              <a:t>ไม่คุ้มที่จะรื้อระบบที่กำลังจะปิด — เป็นการประหยัดที่ใหญ่ที่สุดจากเงื่อนไขใหม่</a:t>
+              <a:t>เทียบผลเก่า–ใหม่ 1 รอบเต็ม · UAT · เกณฑ์ผ่าน/ไม่ผ่าน + แผนย้อนกลับ · เลือกช่วงที่คนมาถอนน้อย</a:t>
             </a:r>
           </a:p>
         </p:txBody>
@@ -6337,7 +6337,7 @@
                 <a:cs typeface="Tahoma"/>
                 <a:ea typeface="Tahoma"/>
               </a:rPr>
-              <a:t>แผนปิดระบบ · เพิ่มใหม่</a:t>
+              <a:t>แผนปิดระบบ · รอกำหนดวัน</a:t>
             </a:r>
           </a:p>
         </p:txBody>
@@ -6384,7 +6384,7 @@
                 <a:cs typeface="Tahoma"/>
                 <a:ea typeface="Tahoma"/>
               </a:rPr>
-              <a:t>กำหนดวันปิด · จัดการยอดที่ไม่มีผู้มาถอน · เก็บข้อมูลถาวร · ปลดระวางเครื่อง</a:t>
+              <a:t>กำหนดวันปิด · จัดการยอดที่ไม่มีผู้มาถอน · เก็บข้อมูลถาวร · ปลดระวางระบบ</a:t>
             </a:r>
           </a:p>
         </p:txBody>
@@ -6857,7 +6857,7 @@
                 <a:cs typeface="Tahoma"/>
                 <a:ea typeface="Tahoma"/>
               </a:rPr>
-              <a:t>ปลายทางของ Feed ยังต้องการข้อมูลไหม</a:t>
+              <a:t>ย้ายแพลตฟอร์มคุ้มกับความเสี่ยงหรือไม่</a:t>
             </a:r>
           </a:p>
         </p:txBody>
@@ -6904,7 +6904,7 @@
                 <a:cs typeface="Tahoma"/>
                 <a:ea typeface="Tahoma"/>
               </a:rPr>
-              <a:t>ถ้าไม่ ตัดได้ทั้งชุด — ประหยัดงานมากที่สุดทันที</a:t>
+              <a:t>ระบบกำลังจะปิดอยู่แล้ว — ถ้าวันปิดใกล้พอ อาจคงระบบเดิมจนถึงวันปิด</a:t>
             </a:r>
           </a:p>
         </p:txBody>
@@ -7086,7 +7086,7 @@
                 <a:cs typeface="Tahoma"/>
                 <a:ea typeface="Tahoma"/>
               </a:rPr>
-              <a:t>เป็นตัวกำหนดว่าจะลงทุนกับระบบแค่ไหน</a:t>
+              <a:t>เป็นตัวกำหนดคำตอบข้อบน และว่าจะลงทุนแค่ไหน</a:t>
             </a:r>
           </a:p>
         </p:txBody>
@@ -7221,7 +7221,7 @@
                 <a:cs typeface="Tahoma"/>
                 <a:ea typeface="Tahoma"/>
               </a:rPr>
-              <a:t>เหลือผู้ถือกี่ราย ยอดคงค้างเท่าไร</a:t>
+              <a:t>ปลายทางของ Feed ยังต้องการข้อมูลไหม</a:t>
             </a:r>
           </a:p>
         </p:txBody>
@@ -7268,7 +7268,7 @@
                 <a:cs typeface="Tahoma"/>
                 <a:ea typeface="Tahoma"/>
               </a:rPr>
-              <a:t>ใช้ประเมินว่าต้องรันระบบอีกนานเท่าใด</a:t>
+              <a:t>ถ้าไม่ ตัดได้ทั้งชุด และไม่ต้องยกไปแพลตฟอร์มใหม่</a:t>
             </a:r>
           </a:p>
         </p:txBody>
@@ -7403,7 +7403,7 @@
                 <a:cs typeface="Tahoma"/>
                 <a:ea typeface="Tahoma"/>
               </a:rPr>
-              <a:t>ยอดจ่ายคืนคิดอย่างไร</a:t>
+              <a:t>เกณฑ์การกระทบยอดที่ยอมรับได้</a:t>
             </a:r>
           </a:p>
         </p:txBody>
@@ -7450,7 +7450,7 @@
                 <a:cs typeface="Tahoma"/>
                 <a:ea typeface="Tahoma"/>
               </a:rPr>
-              <a:t>ยังคิดผลตอบแทนต่อ หรือหยุด ณ วันที่กำหนด</a:t>
+              <a:t>ต้องตรงทุกบาท หรือมีเกณฑ์ผ่อนผัน — ใช้เป็นเกณฑ์ cutover</a:t>
             </a:r>
           </a:p>
         </p:txBody>
@@ -7585,7 +7585,7 @@
                 <a:cs typeface="Tahoma"/>
                 <a:ea typeface="Tahoma"/>
               </a:rPr>
-              <a:t>เงินที่ไม่มีผู้มาถอนจัดการอย่างไร</a:t>
+              <a:t>เหลือผู้ถือกี่ราย ยอดคงค้างเท่าไร</a:t>
             </a:r>
           </a:p>
         </p:txBody>
@@ -7632,7 +7632,7 @@
                 <a:cs typeface="Tahoma"/>
                 <a:ea typeface="Tahoma"/>
               </a:rPr>
-              <a:t>ตามระเบียบใด และต้องมีรายงานอะไรรองรับ</a:t>
+              <a:t>ใช้ประเมินว่าต้องรันระบบอีกนานเท่าใด</a:t>
             </a:r>
           </a:p>
         </p:txBody>
@@ -7736,7 +7736,7 @@
                 <a:cs typeface="Tahoma"/>
                 <a:ea typeface="Tahoma"/>
               </a:rPr>
-              <a:t>เริ่ม Phase 1 ได้ทันทีโดยไม่ต้องรอคำตอบข้ออื่น — เป็นงานที่ใช้เวลาน้อยแต่ลดความเสี่ยงได้มากที่สุด</a:t>
+              <a:t>เริ่ม Phase 1 บนระบบเดิมได้ทันที ไม่ต้องรอคำตอบข้ออื่นและไม่ต้องรอการย้ายแพลตฟอร์ม</a:t>
             </a:r>
           </a:p>
         </p:txBody>
@@ -8367,7 +8367,7 @@
                 <a:cs typeface="Tahoma"/>
                 <a:ea typeface="Tahoma"/>
               </a:rPr>
-              <a:t>  — ปิดการขายแล้ว เหลือรอจ่ายคืน</a:t>
+              <a:t>  — ปิดการขาย + ย้ายแพลตฟอร์ม</a:t>
             </a:r>
           </a:p>
           <a:p>
@@ -8402,7 +8402,7 @@
                 <a:cs typeface="Tahoma"/>
                 <a:ea typeface="Tahoma"/>
               </a:rPr>
-              <a:t>2. สิ่งที่เปลี่ยนจากแผนเดิม</a:t>
+              <a:t>2. ย้ายจากอะไร ไปเป็นอะไร</a:t>
             </a:r>
             <a:r>
               <a:rPr sz="1700" b="0">
@@ -8413,7 +8413,7 @@
                 <a:cs typeface="Tahoma"/>
                 <a:ea typeface="Tahoma"/>
               </a:rPr>
-              <a:t>  — เหตุผลเชิงลงทุนเปลี่ยนทั้งหมด</a:t>
+              <a:t>  — AS IS / TO BE</a:t>
             </a:r>
           </a:p>
           <a:p>
@@ -8459,7 +8459,7 @@
                 <a:cs typeface="Tahoma"/>
                 <a:ea typeface="Tahoma"/>
               </a:rPr>
-              <a:t>  — คงไว้อะไร ตัดอะไร</a:t>
+              <a:t>  — ย้ายแค่ไหนก็พอ</a:t>
             </a:r>
           </a:p>
           <a:p>
@@ -8494,7 +8494,7 @@
                 <a:cs typeface="Tahoma"/>
                 <a:ea typeface="Tahoma"/>
               </a:rPr>
-              <a:t>4. ความเสี่ยงที่ยังต้องปิด</a:t>
+              <a:t>4. ความเสี่ยง</a:t>
             </a:r>
             <a:r>
               <a:rPr sz="1700" b="0">
@@ -8505,7 +8505,7 @@
                 <a:cs typeface="Tahoma"/>
                 <a:ea typeface="Tahoma"/>
               </a:rPr>
-              <a:t>  — ปิดการขายไม่ได้ทำให้ปลอดภัยขึ้น</a:t>
+              <a:t>  — ความถูกต้องของเงินลูกค้าคือหัวใจ</a:t>
             </a:r>
           </a:p>
           <a:p>
@@ -8551,7 +8551,7 @@
                 <a:cs typeface="Tahoma"/>
                 <a:ea typeface="Tahoma"/>
               </a:rPr>
-              <a:t>  — ให้เห็นภาพก่อนตัดสินใจ</a:t>
+              <a:t>  — ใช้เป็นสเปกตั้งต้นของระบบใหม่</a:t>
             </a:r>
           </a:p>
           <a:p>
@@ -8586,7 +8586,7 @@
                 <a:cs typeface="Tahoma"/>
                 <a:ea typeface="Tahoma"/>
               </a:rPr>
-              <a:t>6. แผนงานที่ปรับใหม่</a:t>
+              <a:t>6. แผนงาน 5 เฟส</a:t>
             </a:r>
             <a:r>
               <a:rPr sz="1700" b="0">
@@ -8597,7 +8597,7 @@
                 <a:cs typeface="Tahoma"/>
                 <a:ea typeface="Tahoma"/>
               </a:rPr>
-              <a:t>  — ตัดอะไร เพิ่มอะไร</a:t>
+              <a:t>  — ความปลอดภัยก่อน ย้ายทีหลัง</a:t>
             </a:r>
           </a:p>
           <a:p>
@@ -9040,8 +9040,8 @@
         </p:nvSpPr>
         <p:spPr>
           <a:xfrm>
-            <a:off x="914400" y="1481328"/>
-            <a:ext cx="10424160" cy="960120"/>
+            <a:off x="914400" y="1444752"/>
+            <a:ext cx="10424160" cy="1005840"/>
           </a:xfrm>
           <a:prstGeom prst="rect">
             <a:avLst/>
@@ -9062,11 +9062,11 @@
                 <a:spcPts val="0"/>
               </a:spcBef>
               <a:spcAft>
-                <a:spcPts val="300"/>
+                <a:spcPts val="200"/>
               </a:spcAft>
             </a:pPr>
             <a:r>
-              <a:rPr sz="1800" b="0">
+              <a:rPr sz="1700" b="0">
                 <a:solidFill>
                   <a:srgbClr val="222B36"/>
                 </a:solidFill>
@@ -9077,7 +9077,7 @@
               <a:t>ระบบเข้าสู่ </a:t>
             </a:r>
             <a:r>
-              <a:rPr sz="1800" b="1">
+              <a:rPr sz="1700" b="1">
                 <a:solidFill>
                   <a:srgbClr val="B98612"/>
                 </a:solidFill>
@@ -9088,7 +9088,7 @@
               <a:t>โหมดจ่ายคืน (Run-off)</a:t>
             </a:r>
             <a:r>
-              <a:rPr sz="1800" b="0">
+              <a:rPr sz="1700" b="0">
                 <a:solidFill>
                   <a:srgbClr val="222B36"/>
                 </a:solidFill>
@@ -9096,7 +9096,7 @@
                 <a:cs typeface="Tahoma"/>
                 <a:ea typeface="Tahoma"/>
               </a:rPr>
-              <a:t> — ไม่มีการขายใหม่ เหลือเพียงรอให้ผู้ถือสลากมาถอน</a:t>
+              <a:t> — ไม่มีการขายใหม่ เหลือเพียงรอผู้ถือสลากมาถอน</a:t>
             </a:r>
           </a:p>
           <a:p>
@@ -9108,11 +9108,57 @@
                 <a:spcPts val="0"/>
               </a:spcBef>
               <a:spcAft>
-                <a:spcPts val="300"/>
+                <a:spcPts val="200"/>
               </a:spcAft>
             </a:pPr>
             <a:r>
-              <a:rPr sz="1300" b="0">
+              <a:rPr sz="1700" b="0">
+                <a:solidFill>
+                  <a:srgbClr val="222B36"/>
+                </a:solidFill>
+                <a:latin typeface="Tahoma"/>
+                <a:cs typeface="Tahoma"/>
+                <a:ea typeface="Tahoma"/>
+              </a:rPr>
+              <a:t>และ </a:t>
+            </a:r>
+            <a:r>
+              <a:rPr sz="1700" b="1">
+                <a:solidFill>
+                  <a:srgbClr val="234D80"/>
+                </a:solidFill>
+                <a:latin typeface="Tahoma"/>
+                <a:cs typeface="Tahoma"/>
+                <a:ea typeface="Tahoma"/>
+              </a:rPr>
+              <a:t>มีมติย้ายแพลตฟอร์มแล้ว</a:t>
+            </a:r>
+            <a:r>
+              <a:rPr sz="1700" b="0">
+                <a:solidFill>
+                  <a:srgbClr val="222B36"/>
+                </a:solidFill>
+                <a:latin typeface="Tahoma"/>
+                <a:cs typeface="Tahoma"/>
+                <a:ea typeface="Tahoma"/>
+              </a:rPr>
+              <a:t> — ไป Linux + Docker + PostgreSQL</a:t>
+            </a:r>
+          </a:p>
+          <a:p>
+            <a:pPr algn="l">
+              <a:lnSpc>
+                <a:spcPct val="100000"/>
+              </a:lnSpc>
+              <a:spcBef>
+                <a:spcPts val="0"/>
+              </a:spcBef>
+              <a:spcAft>
+                <a:spcPts val="200"/>
+              </a:spcAft>
+            </a:pPr>
+            <a:r>
+              <a:rPr sz="1250" b="0">
                 <a:solidFill>
                   <a:srgbClr val="5A6672"/>
                 </a:solidFill>
@@ -9120,7 +9166,7 @@
                 <a:cs typeface="Tahoma"/>
                 <a:ea typeface="Tahoma"/>
               </a:rPr>
-              <a:t>เป้าหมายของระบบเปลี่ยนจาก 'ให้บริการต่อเนื่อง' เป็น 'จ่ายคืนให้ครบ แล้วปิดระบบ'</a:t>
+              <a:t>สองงานใหญ่นี้เกิดพร้อมกัน ต้องวางลำดับให้ชัด</a:t>
             </a:r>
           </a:p>
         </p:txBody>
@@ -9302,7 +9348,7 @@
                 <a:cs typeface="Tahoma"/>
                 <a:ea typeface="Tahoma"/>
               </a:rPr>
-              <a:t>งานที่ต้องทำลดลงมาก</a:t>
+              <a:t>ขอบเขตลดลงมาก</a:t>
             </a:r>
             <a:r>
               <a:rPr sz="1450" b="0">
@@ -9313,7 +9359,7 @@
                 <a:cs typeface="Tahoma"/>
                 <a:ea typeface="Tahoma"/>
               </a:rPr>
-              <a:t> — เหลือเฉพาะการจ่ายคืน ความปลอดภัย และแผนปิดระบบ</a:t>
+              <a:t> — ย้ายเฉพาะ 8 ฟังก์ชันที่ยังใช้จริง ไม่ต้องยกไปทั้งระบบ</a:t>
             </a:r>
           </a:p>
         </p:txBody>
@@ -9448,7 +9494,7 @@
                 <a:cs typeface="Tahoma"/>
                 <a:ea typeface="Tahoma"/>
               </a:rPr>
-              <a:t>ไม่ควรลงทุนรื้อระบบอีกแล้ว</a:t>
+              <a:t>รันไทม์เก่าแก้ที่ต้นเหตุ</a:t>
             </a:r>
             <a:r>
               <a:rPr sz="1450" b="0">
@@ -9459,7 +9505,7 @@
                 <a:cs typeface="Tahoma"/>
                 <a:ea typeface="Tahoma"/>
               </a:rPr>
-              <a:t> — งานยกระดับสถาปัตยกรรมและ CI/CD ควรพับเก็บ</a:t>
+              <a:t> — การย้ายแพลตฟอร์มแก้ปัญหา Java/GlassFish หมดการสนับสนุน</a:t>
             </a:r>
           </a:p>
         </p:txBody>
@@ -9594,7 +9640,7 @@
                 <a:cs typeface="Tahoma"/>
                 <a:ea typeface="Tahoma"/>
               </a:rPr>
-              <a:t>ความปลอดภัยยังต้องแก้เท่าเดิม</a:t>
+              <a:t>ความเสี่ยงย้ายไปอยู่ที่ข้อมูล</a:t>
             </a:r>
             <a:r>
               <a:rPr sz="1450" b="0">
@@ -9605,7 +9651,7 @@
                 <a:cs typeface="Tahoma"/>
                 <a:ea typeface="Tahoma"/>
               </a:rPr>
-              <a:t> — ข้อมูลลูกค้าและเงินยังอยู่ในระบบ</a:t>
+              <a:t> — MS SQL → PostgreSQL ต้องพิสูจน์ว่ายอดเงินตรงทุกบาท</a:t>
             </a:r>
           </a:p>
         </p:txBody>
@@ -9669,7 +9715,7 @@
             <a:avLst/>
           </a:prstGeom>
           <a:solidFill>
-            <a:srgbClr val="234D80"/>
+            <a:srgbClr val="B13A3F"/>
           </a:solidFill>
           <a:ln>
             <a:noFill/>
@@ -9740,7 +9786,7 @@
                 <a:cs typeface="Tahoma"/>
                 <a:ea typeface="Tahoma"/>
               </a:rPr>
-              <a:t>ต้องเพิ่มเรื่องที่แผนเดิมไม่มี</a:t>
+              <a:t>ความปลอดภัยรอไม่ได้</a:t>
             </a:r>
             <a:r>
               <a:rPr sz="1450" b="0">
@@ -9751,7 +9797,7 @@
                 <a:cs typeface="Tahoma"/>
                 <a:ea typeface="Tahoma"/>
               </a:rPr>
-              <a:t> — แผนปิดระบบ และการจัดการยอดที่ไม่มีผู้มาถอน</a:t>
+              <a:t> — การย้ายใช้เวลาหลายเดือน ต้องแก้รหัสผ่านบนระบบเดิมทันที</a:t>
             </a:r>
           </a:p>
         </p:txBody>
@@ -10042,7 +10088,7 @@
                 <a:cs typeface="Tahoma"/>
                 <a:ea typeface="Tahoma"/>
               </a:rPr>
-              <a:t>สิ่งที่เปลี่ยน</a:t>
+              <a:t>การย้ายแพลตฟอร์ม</a:t>
             </a:r>
           </a:p>
         </p:txBody>
@@ -10089,7 +10135,7 @@
                 <a:cs typeface="Tahoma"/>
                 <a:ea typeface="Tahoma"/>
               </a:rPr>
-              <a:t>เหตุผลเชิงลงทุนเปลี่ยนทั้งหมด</a:t>
+              <a:t>ย้ายจากอะไร ไปเป็นอะไร</a:t>
             </a:r>
           </a:p>
         </p:txBody>
@@ -10315,7 +10361,7 @@
                 <a:cs typeface="Tahoma"/>
                 <a:ea typeface="Tahoma"/>
               </a:rPr>
-              <a:t>แผนเดิม (ระบบเปิดขาย)</a:t>
+              <a:t>AS IS — ระบบเดิม</a:t>
             </a:r>
           </a:p>
         </p:txBody>
@@ -10362,7 +10408,7 @@
                 <a:cs typeface="Tahoma"/>
                 <a:ea typeface="Tahoma"/>
               </a:rPr>
-              <a:t>แผนใหม่ (โหมดจ่ายคืน)</a:t>
+              <a:t>TO BE — แพลตฟอร์มใหม่</a:t>
             </a:r>
           </a:p>
         </p:txBody>
@@ -10547,7 +10593,7 @@
                 <a:cs typeface="Tahoma"/>
                 <a:ea typeface="Tahoma"/>
               </a:rPr>
-              <a:t>เป้าหมายระบบ</a:t>
+              <a:t>ระบบปฏิบัติการ</a:t>
             </a:r>
           </a:p>
         </p:txBody>
@@ -10594,7 +10640,7 @@
                 <a:cs typeface="Tahoma"/>
                 <a:ea typeface="Tahoma"/>
               </a:rPr>
-              <a:t>ให้บริการต่อเนื่องระยะยาว</a:t>
+              <a:t>Windows Server 2019 (2 เครื่อง)</a:t>
             </a:r>
           </a:p>
         </p:txBody>
@@ -10641,7 +10687,7 @@
                 <a:cs typeface="Tahoma"/>
                 <a:ea typeface="Tahoma"/>
               </a:rPr>
-              <a:t>จ่ายคืนผู้ถือให้ครบ แล้วปิดระบบ</a:t>
+              <a:t>Linux (Ubuntu) + Docker</a:t>
             </a:r>
           </a:p>
         </p:txBody>
@@ -10826,7 +10872,7 @@
                 <a:cs typeface="Tahoma"/>
                 <a:ea typeface="Tahoma"/>
               </a:rPr>
-              <a:t>ยกระดับ/พัฒนาใหม่</a:t>
+              <a:t>ฐานข้อมูล</a:t>
             </a:r>
           </a:p>
         </p:txBody>
@@ -10873,7 +10919,7 @@
                 <a:cs typeface="Tahoma"/>
                 <a:ea typeface="Tahoma"/>
               </a:rPr>
-              <a:t>เสนอให้ประเมิน</a:t>
+              <a:t>MS SQL Server 2019</a:t>
             </a:r>
           </a:p>
         </p:txBody>
@@ -10920,7 +10966,7 @@
                 <a:cs typeface="Tahoma"/>
                 <a:ea typeface="Tahoma"/>
               </a:rPr>
-              <a:t>ตัดออก — ไม่คุ้มที่จะรื้อระบบที่จะปิด</a:t>
+              <a:t>PostgreSQL</a:t>
             </a:r>
           </a:p>
         </p:txBody>
@@ -11105,7 +11151,7 @@
                 <a:cs typeface="Tahoma"/>
                 <a:ea typeface="Tahoma"/>
               </a:rPr>
-              <a:t>ความพร้อมใช้งาน (HA)</a:t>
+              <a:t>รันไทม์แอป</a:t>
             </a:r>
           </a:p>
         </p:txBody>
@@ -11152,7 +11198,7 @@
                 <a:cs typeface="Tahoma"/>
                 <a:ea typeface="Tahoma"/>
               </a:rPr>
-              <a:t>ต้องการสูง</a:t>
+              <a:t>Java 1.6 + GlassFish (หมดการสนับสนุน)</a:t>
             </a:r>
           </a:p>
         </p:txBody>
@@ -11199,7 +11245,7 @@
                 <a:cs typeface="Tahoma"/>
                 <a:ea typeface="Tahoma"/>
               </a:rPr>
-              <a:t>ลดระดับได้ — ธุรกรรมต่ำมาก</a:t>
+              <a:t>บริการแยก container ที่ยังได้รับแพตช์</a:t>
             </a:r>
           </a:p>
         </p:txBody>
@@ -11384,7 +11430,7 @@
                 <a:cs typeface="Tahoma"/>
                 <a:ea typeface="Tahoma"/>
               </a:rPr>
-              <a:t>เวลากู้คืน (RTO)</a:t>
+              <a:t>ตรรกะธุรกิจ</a:t>
             </a:r>
           </a:p>
         </p:txBody>
@@ -11431,7 +11477,7 @@
                 <a:cs typeface="Tahoma"/>
                 <a:ea typeface="Tahoma"/>
               </a:rPr>
-              <a:t>ต้องสั้น</a:t>
+              <a:t>อยู่ใน Stored Procedure</a:t>
             </a:r>
           </a:p>
         </p:txBody>
@@ -11478,7 +11524,7 @@
                 <a:cs typeface="Tahoma"/>
                 <a:ea typeface="Tahoma"/>
               </a:rPr>
-              <a:t>ยืดหยุ่นได้</a:t>
+              <a:t>ย้ายมาอยู่ในชั้นแอป</a:t>
             </a:r>
           </a:p>
         </p:txBody>
@@ -11663,7 +11709,7 @@
                 <a:cs typeface="Tahoma"/>
                 <a:ea typeface="Tahoma"/>
               </a:rPr>
-              <a:t>ความปลอดภัย</a:t>
+              <a:t>ขอบเขตที่ต้องย้าย</a:t>
             </a:r>
           </a:p>
         </p:txBody>
@@ -11710,7 +11756,7 @@
                 <a:cs typeface="Tahoma"/>
                 <a:ea typeface="Tahoma"/>
               </a:rPr>
-              <a:t>ต้องแก้</a:t>
+              <a:t>21 ฟังก์ชัน รวมงานขายที่เลิกใช้</a:t>
             </a:r>
           </a:p>
         </p:txBody>
@@ -11757,7 +11803,7 @@
                 <a:cs typeface="Tahoma"/>
                 <a:ea typeface="Tahoma"/>
               </a:rPr>
-              <a:t>ยังต้องแก้เหมือนเดิม</a:t>
+              <a:t>เฉพาะ 8 ฟังก์ชันที่ยังใช้จริง</a:t>
             </a:r>
           </a:p>
         </p:txBody>
@@ -11942,7 +11988,7 @@
                 <a:cs typeface="Tahoma"/>
                 <a:ea typeface="Tahoma"/>
               </a:rPr>
-              <a:t>ร่องรอยตรวจสอบ</a:t>
+              <a:t>งานส่งข้อมูลออก</a:t>
             </a:r>
           </a:p>
         </p:txBody>
@@ -11989,7 +12035,7 @@
                 <a:cs typeface="Tahoma"/>
                 <a:ea typeface="Tahoma"/>
               </a:rPr>
-              <a:t>ต้องมี</a:t>
+              <a:t>งานตามเวลาแบบ Windows (.bat)</a:t>
             </a:r>
           </a:p>
         </p:txBody>
@@ -12036,7 +12082,7 @@
                 <a:cs typeface="Tahoma"/>
                 <a:ea typeface="Tahoma"/>
               </a:rPr>
-              <a:t>สำคัญขึ้น — เป็นหลักฐานการจ่ายคืน</a:t>
+              <a:t>แบบ Linux (.sh) หรือยกเลิกทั้งชุด</a:t>
             </a:r>
           </a:p>
         </p:txBody>
@@ -12221,7 +12267,7 @@
                 <a:cs typeface="Tahoma"/>
                 <a:ea typeface="Tahoma"/>
               </a:rPr>
-              <a:t>สิ่งที่ต้องเพิ่ม</a:t>
+              <a:t>ความถูกต้องของข้อมูล</a:t>
             </a:r>
           </a:p>
         </p:txBody>
@@ -12315,7 +12361,7 @@
                 <a:cs typeface="Tahoma"/>
                 <a:ea typeface="Tahoma"/>
               </a:rPr>
-              <a:t>แผนปิดระบบ + จัดการยอดที่ไม่มีผู้มาถอน</a:t>
+              <a:t>กระทบยอดทุกบาท + รันคู่ขนานก่อน cutover</a:t>
             </a:r>
           </a:p>
         </p:txBody>
@@ -20541,7 +20587,7 @@
                 <a:cs typeface="Tahoma"/>
                 <a:ea typeface="Tahoma"/>
               </a:rPr>
-              <a:t>ปิดการขายไม่ได้ทำให้ระบบปลอดภัยขึ้น</a:t>
+              <a:t>3 เรื่องที่ต้องจัดการก่อน</a:t>
             </a:r>
           </a:p>
         </p:txBody>
@@ -20588,7 +20634,7 @@
                 <a:cs typeface="Tahoma"/>
                 <a:ea typeface="Tahoma"/>
               </a:rPr>
-              <a:t>ข้อมูลลูกค้าและเงินยังอยู่ในระบบ ผู้ตรวจสอบยังตรวจระบบที่ยังมีข้อมูล — 3 เรื่องนี้ยังเร่งด่วนเท่าเดิม</a:t>
+              <a:t>ความเสี่ยงใหญ่ที่สุดย้ายจาก 'รันไทม์เก่า' ไปเป็น 'ความถูกต้องของข้อมูลตอนย้าย' — เพราะระบบนี้เก็บเงินลูกค้า</a:t>
             </a:r>
           </a:p>
         </p:txBody>
@@ -20921,7 +20967,7 @@
                 <a:cs typeface="Tahoma"/>
                 <a:ea typeface="Tahoma"/>
               </a:rPr>
-              <a:t>ผู้ที่เข้าถึงเอกสารได้ = เข้าถึงข้อมูลลูกค้าและรายการจ่ายเงินได้ทันที</a:t>
+              <a:t>ต้องแก้บนระบบเดิมทันที ไม่ต้องรอการย้าย เพราะการย้ายใช้เวลาหลายเดือน</a:t>
             </a:r>
           </a:p>
         </p:txBody>
@@ -21149,7 +21195,7 @@
                 <a:cs typeface="Tahoma"/>
                 <a:ea typeface="Tahoma"/>
               </a:rPr>
-              <a:t>โปรแกรมพื้นฐานหมดการสนับสนุน</a:t>
+              <a:t>การย้ายข้อมูล MS SQL → PostgreSQL</a:t>
             </a:r>
           </a:p>
         </p:txBody>
@@ -21196,7 +21242,7 @@
                 <a:cs typeface="Tahoma"/>
                 <a:ea typeface="Tahoma"/>
               </a:rPr>
-              <a:t>ตัวรันโปรแกรมและตัวให้บริการเว็บที่ใช้อยู่ ไม่มีผู้ผลิตดูแลและออกแพตช์แล้ว</a:t>
+              <a:t>ตรรกะอยู่ใน Stored Procedure ซึ่งย้ายตรง ๆ ไม่ได้ ต้องเขียนใหม่และพิสูจน์ว่าให้ผลเหมือนเดิม</a:t>
             </a:r>
           </a:p>
         </p:txBody>
@@ -21254,7 +21300,7 @@
                 <a:cs typeface="Tahoma"/>
                 <a:ea typeface="Tahoma"/>
               </a:rPr>
-              <a:t>ช่องโหว่ที่พบใหม่จะไม่มีทางแก้ และไม่ผ่านการสแกนตามมาตรฐานธนาคาร</a:t>
+              <a:t>หากคำนวณเพี้ยน = จ่ายคืนผิดจำนวน แก้ย้อนหลังยาก ต้องกระทบยอดทุกบาท + รันคู่ขนานก่อน cutover</a:t>
             </a:r>
           </a:p>
         </p:txBody>
@@ -21482,7 +21528,7 @@
                 <a:cs typeface="Tahoma"/>
                 <a:ea typeface="Tahoma"/>
               </a:rPr>
-              <a:t>ไม่มีเครื่องสำรองและยังไม่ได้ตกลงเวลากู้คืน</a:t>
+              <a:t>ทำสองงานใหญ่พร้อมกันบนทีมเดียว</a:t>
             </a:r>
           </a:p>
         </p:txBody>
@@ -21529,7 +21575,7 @@
                 <a:cs typeface="Tahoma"/>
                 <a:ea typeface="Tahoma"/>
               </a:rPr>
-              <a:t>มีเครื่องละ 1 ตัว หากเสียหายต้องกู้คืนใหม่ทั้งหมด</a:t>
+              <a:t>ระบบกำลังปิดตัวและย้ายแพลตฟอร์มไปพร้อมกัน ขณะที่สาขาก็ทยอยปิด</a:t>
             </a:r>
           </a:p>
         </p:txBody>
@@ -21587,7 +21633,7 @@
                 <a:cs typeface="Tahoma"/>
                 <a:ea typeface="Tahoma"/>
               </a:rPr>
-              <a:t>ระดับความเร่งด่วนลดลงได้ในโหมดนี้ แต่ยังต้องตกลงเวลากู้คืนที่ยอมรับได้</a:t>
+              <a:t>ต้องเรียงลำดับให้ชัด — ความปลอดภัยก่อน ย้ายแพลตฟอร์มทีหลัง</a:t>
             </a:r>
           </a:p>
         </p:txBody>

</xml_diff>